<commit_message>
Remove Investment slide (placeholder) — deck now 11 slides
</commit_message>
<xml_diff>
--- a/deck/outdoor-ie-booking-deck.pptx
+++ b/deck/outdoor-ie-booking-deck.pptx
@@ -16,10 +16,9 @@
     <p:sldId id="264" r:id="rId10"/>
     <p:sldId id="265" r:id="rId11"/>
     <p:sldId id="266" r:id="rId12"/>
-    <p:sldId id="267" r:id="rId13"/>
   </p:sldIdLst>
   <p:notesMasterIdLst>
-    <p:notesMasterId r:id="rId14"/>
+    <p:notesMasterId r:id="rId13"/>
   </p:notesMasterIdLst>
   <p:sldSz cx="12192000" cy="6858000"/>
   <p:notesSz cx="6858000" cy="12192000"/>
@@ -601,7 +600,7 @@
           <a:p>
             <a:r>
               <a:rPr lang="en-US" dirty="0"/>
-              <a:t>GTM on their own site: button at intent, intercept not interrupt, keep the form, promote in follow-ups.</a:t>
+              <a:t>The ask: WordPress admin, a Cal.com account (or we make one), the bookings email, and their go-ahead.</a:t>
             </a:r>
             <a:endParaRPr lang="en-US" dirty="0"/>
           </a:p>
@@ -689,7 +688,7 @@
           <a:p>
             <a:r>
               <a:rPr lang="en-US" dirty="0"/>
-              <a:t>The ask: WordPress admin, a Cal.com account (or we make one), the bookings email, and their go-ahead.</a:t>
+              <a:t>Closing: From zero to logged. Reclaim the warm lead and the scheduling time. Contact Loggdin.</a:t>
             </a:r>
             <a:endParaRPr lang="en-US" dirty="0"/>
           </a:p>
@@ -713,94 +712,6 @@
             <a:fld id="{F7021451-1387-4CA6-816F-3879F97B5CBC}" type="slidenum">
               <a:rPr lang="en-US"/>
               <a:t>11</a:t>
-            </a:fld>
-            <a:endParaRPr lang="en-US"/>
-          </a:p>
-        </p:txBody>
-      </p:sp>
-    </p:spTree>
-    <p:extLst>
-      <p:ext uri="{BB962C8B-B14F-4D97-AF65-F5344CB8AC3E}">
-        <p14:creationId xmlns:p14="http://schemas.microsoft.com/office/powerpoint/2010/main" val="1024086991"/>
-      </p:ext>
-    </p:extLst>
-  </p:cSld>
-  <p:clrMapOvr>
-    <a:masterClrMapping/>
-  </p:clrMapOvr>
-</p:notes>
-</file>
-
-<file path=ppt/notesSlides/notesSlide12.xml><?xml version="1.0" encoding="utf-8"?>
-<p:notes xmlns:a="http://schemas.openxmlformats.org/drawingml/2006/main" xmlns:r="http://schemas.openxmlformats.org/officeDocument/2006/relationships" xmlns:p="http://schemas.openxmlformats.org/presentationml/2006/main">
-  <p:cSld>
-    <p:spTree>
-      <p:nvGrpSpPr>
-        <p:cNvPr id="1" name=""/>
-        <p:cNvGrpSpPr/>
-        <p:nvPr/>
-      </p:nvGrpSpPr>
-      <p:grpSpPr>
-        <a:xfrm>
-          <a:off x="0" y="0"/>
-          <a:ext cx="0" cy="0"/>
-          <a:chOff x="0" y="0"/>
-          <a:chExt cx="0" cy="0"/>
-        </a:xfrm>
-      </p:grpSpPr>
-      <p:sp>
-        <p:nvSpPr>
-          <p:cNvPr id="2" name="Slide Image Placeholder 1"/>
-          <p:cNvSpPr>
-            <a:spLocks noGrp="1" noRot="1" noChangeAspect="1"/>
-          </p:cNvSpPr>
-          <p:nvPr>
-            <p:ph type="sldImg"/>
-          </p:nvPr>
-        </p:nvSpPr>
-        <p:spPr/>
-      </p:sp>
-      <p:sp>
-        <p:nvSpPr>
-          <p:cNvPr id="3" name="Notes Placeholder 2"/>
-          <p:cNvSpPr>
-            <a:spLocks noGrp="1"/>
-          </p:cNvSpPr>
-          <p:nvPr>
-            <p:ph type="body" idx="1"/>
-          </p:nvPr>
-        </p:nvSpPr>
-        <p:spPr/>
-        <p:txBody>
-          <a:bodyPr/>
-          <a:lstStyle/>
-          <a:p>
-            <a:r>
-              <a:rPr lang="en-US" dirty="0"/>
-              <a:t>Closing: From zero to logged. Reclaim the warm lead and the scheduling time. Contact Loggdin.</a:t>
-            </a:r>
-            <a:endParaRPr lang="en-US" dirty="0"/>
-          </a:p>
-        </p:txBody>
-      </p:sp>
-      <p:sp>
-        <p:nvSpPr>
-          <p:cNvPr id="4" name="Slide Number Placeholder 3"/>
-          <p:cNvSpPr>
-            <a:spLocks noGrp="1"/>
-          </p:cNvSpPr>
-          <p:nvPr>
-            <p:ph type="sldNum" sz="quarter" idx="10"/>
-          </p:nvPr>
-        </p:nvSpPr>
-        <p:spPr/>
-        <p:txBody>
-          <a:bodyPr/>
-          <a:lstStyle/>
-          <a:p>
-            <a:fld id="{F7021451-1387-4CA6-816F-3879F97B5CBC}" type="slidenum">
-              <a:rPr lang="en-US"/>
-              <a:t>12</a:t>
             </a:fld>
             <a:endParaRPr lang="en-US"/>
           </a:p>
@@ -1305,7 +1216,7 @@
           <a:p>
             <a:r>
               <a:rPr lang="en-US" dirty="0"/>
-              <a:t>Investment slide. Figures are placeholders — confirm against the quote document and fill in real numbers.</a:t>
+              <a:t>Value: captures leads round the clock, removes staff scheduling, uses existing WordPress, reduces lost enquiries.</a:t>
             </a:r>
             <a:endParaRPr lang="en-US" dirty="0"/>
           </a:p>
@@ -1393,7 +1304,7 @@
           <a:p>
             <a:r>
               <a:rPr lang="en-US" dirty="0"/>
-              <a:t>Value: captures leads round the clock, removes staff scheduling, uses existing WordPress, reduces lost enquiries.</a:t>
+              <a:t>Phased rollout: preview, Cal.com setup, go live with button, expand to other services, review insights.</a:t>
             </a:r>
             <a:endParaRPr lang="en-US" dirty="0"/>
           </a:p>
@@ -1481,7 +1392,7 @@
           <a:p>
             <a:r>
               <a:rPr lang="en-US" dirty="0"/>
-              <a:t>Phased rollout: preview, Cal.com setup, go live with button, expand to other services, review insights.</a:t>
+              <a:t>GTM on their own site: button at intent, intercept not interrupt, keep the form, promote in follow-ups.</a:t>
             </a:r>
             <a:endParaRPr lang="en-US" dirty="0"/>
           </a:p>
@@ -2127,551 +2038,6 @@
     <p:bg>
       <p:bgPr>
         <a:solidFill>
-          <a:srgbClr val="FFFFFF"/>
-        </a:solidFill>
-      </p:bgPr>
-    </p:bg>
-    <p:spTree>
-      <p:nvGrpSpPr>
-        <p:cNvPr id="1" name=""/>
-        <p:cNvGrpSpPr/>
-        <p:nvPr/>
-      </p:nvGrpSpPr>
-      <p:grpSpPr>
-        <a:xfrm>
-          <a:off x="0" y="0"/>
-          <a:ext cx="0" cy="0"/>
-          <a:chOff x="0" y="0"/>
-          <a:chExt cx="0" cy="0"/>
-        </a:xfrm>
-      </p:grpSpPr>
-      <p:sp>
-        <p:nvSpPr>
-          <p:cNvPr id="2" name="Text 0"/>
-          <p:cNvSpPr/>
-          <p:nvPr/>
-        </p:nvSpPr>
-        <p:spPr>
-          <a:xfrm>
-            <a:off x="822960" y="640080"/>
-            <a:ext cx="8229600" cy="292608"/>
-          </a:xfrm>
-          <a:prstGeom prst="rect">
-            <a:avLst/>
-          </a:prstGeom>
-          <a:noFill/>
-          <a:ln/>
-        </p:spPr>
-        <p:txBody>
-          <a:bodyPr wrap="square" rtlCol="0" anchor="ctr"/>
-          <a:lstStyle/>
-          <a:p>
-            <a:pPr algn="l" indent="0" marL="0">
-              <a:buNone/>
-            </a:pPr>
-            <a:r>
-              <a:rPr lang="en-US" sz="1250" b="1" spc="300" kern="0" dirty="0">
-                <a:solidFill>
-                  <a:srgbClr val="16513C"/>
-                </a:solidFill>
-                <a:latin typeface="Courier New" pitchFamily="34" charset="0"/>
-                <a:ea typeface="Courier New" pitchFamily="34" charset="-122"/>
-                <a:cs typeface="Courier New" pitchFamily="34" charset="-120"/>
-              </a:rPr>
-              <a:t>GO TO MARKET</a:t>
-            </a:r>
-            <a:endParaRPr lang="en-US" sz="1250" dirty="0"/>
-          </a:p>
-        </p:txBody>
-      </p:sp>
-      <p:sp>
-        <p:nvSpPr>
-          <p:cNvPr id="3" name="Text 1"/>
-          <p:cNvSpPr/>
-          <p:nvPr/>
-        </p:nvSpPr>
-        <p:spPr>
-          <a:xfrm>
-            <a:off x="822960" y="960120"/>
-            <a:ext cx="10607040" cy="1051560"/>
-          </a:xfrm>
-          <a:prstGeom prst="rect">
-            <a:avLst/>
-          </a:prstGeom>
-          <a:noFill/>
-          <a:ln/>
-        </p:spPr>
-        <p:txBody>
-          <a:bodyPr wrap="square" rtlCol="0" anchor="t"/>
-          <a:lstStyle/>
-          <a:p>
-            <a:pPr algn="l" indent="0" marL="0">
-              <a:lnSpc>
-                <a:spcPts val="3600"/>
-              </a:lnSpc>
-              <a:buNone/>
-            </a:pPr>
-            <a:r>
-              <a:rPr lang="en-US" sz="3300" b="1" dirty="0">
-                <a:solidFill>
-                  <a:srgbClr val="16201C"/>
-                </a:solidFill>
-                <a:latin typeface="Arial" pitchFamily="34" charset="0"/>
-                <a:ea typeface="Arial" pitchFamily="34" charset="-122"/>
-                <a:cs typeface="Arial" pitchFamily="34" charset="-120"/>
-              </a:rPr>
-              <a:t>Catching customers at intent</a:t>
-            </a:r>
-            <a:endParaRPr lang="en-US" sz="3300" dirty="0"/>
-          </a:p>
-        </p:txBody>
-      </p:sp>
-      <p:sp>
-        <p:nvSpPr>
-          <p:cNvPr id="4" name="Shape 2"/>
-          <p:cNvSpPr/>
-          <p:nvPr/>
-        </p:nvSpPr>
-        <p:spPr>
-          <a:xfrm>
-            <a:off x="822960" y="2514600"/>
-            <a:ext cx="5120640" cy="1737360"/>
-          </a:xfrm>
-          <a:prstGeom prst="roundRect">
-            <a:avLst>
-              <a:gd name="adj" fmla="val 4737"/>
-            </a:avLst>
-          </a:prstGeom>
-          <a:solidFill>
-            <a:srgbClr val="F4F6F4"/>
-          </a:solidFill>
-          <a:ln w="12700">
-            <a:solidFill>
-              <a:srgbClr val="E2E4E0"/>
-            </a:solidFill>
-            <a:prstDash val="solid"/>
-          </a:ln>
-        </p:spPr>
-      </p:sp>
-      <p:sp>
-        <p:nvSpPr>
-          <p:cNvPr id="5" name="Text 3"/>
-          <p:cNvSpPr/>
-          <p:nvPr/>
-        </p:nvSpPr>
-        <p:spPr>
-          <a:xfrm>
-            <a:off x="1188720" y="2788920"/>
-            <a:ext cx="4389120" cy="457200"/>
-          </a:xfrm>
-          <a:prstGeom prst="rect">
-            <a:avLst/>
-          </a:prstGeom>
-          <a:noFill/>
-          <a:ln/>
-        </p:spPr>
-        <p:txBody>
-          <a:bodyPr wrap="square" rtlCol="0" anchor="ctr"/>
-          <a:lstStyle/>
-          <a:p>
-            <a:pPr indent="0" marL="0">
-              <a:buNone/>
-            </a:pPr>
-            <a:r>
-              <a:rPr lang="en-US" sz="1700" b="1" dirty="0">
-                <a:solidFill>
-                  <a:srgbClr val="16513C"/>
-                </a:solidFill>
-                <a:latin typeface="Arial" pitchFamily="34" charset="0"/>
-                <a:ea typeface="Arial" pitchFamily="34" charset="-122"/>
-                <a:cs typeface="Arial" pitchFamily="34" charset="-120"/>
-              </a:rPr>
-              <a:t>Button on pergola pages</a:t>
-            </a:r>
-            <a:endParaRPr lang="en-US" sz="1700" dirty="0"/>
-          </a:p>
-        </p:txBody>
-      </p:sp>
-      <p:sp>
-        <p:nvSpPr>
-          <p:cNvPr id="6" name="Text 4"/>
-          <p:cNvSpPr/>
-          <p:nvPr/>
-        </p:nvSpPr>
-        <p:spPr>
-          <a:xfrm>
-            <a:off x="1188720" y="3291840"/>
-            <a:ext cx="4389120" cy="777240"/>
-          </a:xfrm>
-          <a:prstGeom prst="rect">
-            <a:avLst/>
-          </a:prstGeom>
-          <a:noFill/>
-          <a:ln/>
-        </p:spPr>
-        <p:txBody>
-          <a:bodyPr wrap="square" rtlCol="0" anchor="ctr"/>
-          <a:lstStyle/>
-          <a:p>
-            <a:pPr indent="0" marL="0">
-              <a:lnSpc>
-                <a:spcPts val="1800"/>
-              </a:lnSpc>
-              <a:buNone/>
-            </a:pPr>
-            <a:r>
-              <a:rPr lang="en-US" sz="1300" dirty="0">
-                <a:solidFill>
-                  <a:srgbClr val="5A6661"/>
-                </a:solidFill>
-                <a:latin typeface="Arial" pitchFamily="34" charset="0"/>
-                <a:ea typeface="Arial" pitchFamily="34" charset="-122"/>
-                <a:cs typeface="Arial" pitchFamily="34" charset="-120"/>
-              </a:rPr>
-              <a:t>'Book a free consultation' sits where the decision is made.</a:t>
-            </a:r>
-            <a:endParaRPr lang="en-US" sz="1300" dirty="0"/>
-          </a:p>
-        </p:txBody>
-      </p:sp>
-      <p:sp>
-        <p:nvSpPr>
-          <p:cNvPr id="7" name="Shape 5"/>
-          <p:cNvSpPr/>
-          <p:nvPr/>
-        </p:nvSpPr>
-        <p:spPr>
-          <a:xfrm>
-            <a:off x="6355080" y="2514600"/>
-            <a:ext cx="5120640" cy="1737360"/>
-          </a:xfrm>
-          <a:prstGeom prst="roundRect">
-            <a:avLst>
-              <a:gd name="adj" fmla="val 4737"/>
-            </a:avLst>
-          </a:prstGeom>
-          <a:solidFill>
-            <a:srgbClr val="F4F6F4"/>
-          </a:solidFill>
-          <a:ln w="12700">
-            <a:solidFill>
-              <a:srgbClr val="E2E4E0"/>
-            </a:solidFill>
-            <a:prstDash val="solid"/>
-          </a:ln>
-        </p:spPr>
-      </p:sp>
-      <p:sp>
-        <p:nvSpPr>
-          <p:cNvPr id="8" name="Text 6"/>
-          <p:cNvSpPr/>
-          <p:nvPr/>
-        </p:nvSpPr>
-        <p:spPr>
-          <a:xfrm>
-            <a:off x="6720840" y="2788920"/>
-            <a:ext cx="4389120" cy="457200"/>
-          </a:xfrm>
-          <a:prstGeom prst="rect">
-            <a:avLst/>
-          </a:prstGeom>
-          <a:noFill/>
-          <a:ln/>
-        </p:spPr>
-        <p:txBody>
-          <a:bodyPr wrap="square" rtlCol="0" anchor="ctr"/>
-          <a:lstStyle/>
-          <a:p>
-            <a:pPr indent="0" marL="0">
-              <a:buNone/>
-            </a:pPr>
-            <a:r>
-              <a:rPr lang="en-US" sz="1700" b="1" dirty="0">
-                <a:solidFill>
-                  <a:srgbClr val="16513C"/>
-                </a:solidFill>
-                <a:latin typeface="Arial" pitchFamily="34" charset="0"/>
-                <a:ea typeface="Arial" pitchFamily="34" charset="-122"/>
-                <a:cs typeface="Arial" pitchFamily="34" charset="-120"/>
-              </a:rPr>
-              <a:t>Intercept, don't interrupt</a:t>
-            </a:r>
-            <a:endParaRPr lang="en-US" sz="1700" dirty="0"/>
-          </a:p>
-        </p:txBody>
-      </p:sp>
-      <p:sp>
-        <p:nvSpPr>
-          <p:cNvPr id="9" name="Text 7"/>
-          <p:cNvSpPr/>
-          <p:nvPr/>
-        </p:nvSpPr>
-        <p:spPr>
-          <a:xfrm>
-            <a:off x="6720840" y="3291840"/>
-            <a:ext cx="4389120" cy="777240"/>
-          </a:xfrm>
-          <a:prstGeom prst="rect">
-            <a:avLst/>
-          </a:prstGeom>
-          <a:noFill/>
-          <a:ln/>
-        </p:spPr>
-        <p:txBody>
-          <a:bodyPr wrap="square" rtlCol="0" anchor="ctr"/>
-          <a:lstStyle/>
-          <a:p>
-            <a:pPr indent="0" marL="0">
-              <a:lnSpc>
-                <a:spcPts val="1800"/>
-              </a:lnSpc>
-              <a:buNone/>
-            </a:pPr>
-            <a:r>
-              <a:rPr lang="en-US" sz="1300" dirty="0">
-                <a:solidFill>
-                  <a:srgbClr val="5A6661"/>
-                </a:solidFill>
-                <a:latin typeface="Arial" pitchFamily="34" charset="0"/>
-                <a:ea typeface="Arial" pitchFamily="34" charset="-122"/>
-                <a:cs typeface="Arial" pitchFamily="34" charset="-120"/>
-              </a:rPr>
-              <a:t>Offer a time to people already interested — not a cold ask.</a:t>
-            </a:r>
-            <a:endParaRPr lang="en-US" sz="1300" dirty="0"/>
-          </a:p>
-        </p:txBody>
-      </p:sp>
-      <p:sp>
-        <p:nvSpPr>
-          <p:cNvPr id="10" name="Shape 8"/>
-          <p:cNvSpPr/>
-          <p:nvPr/>
-        </p:nvSpPr>
-        <p:spPr>
-          <a:xfrm>
-            <a:off x="822960" y="4526280"/>
-            <a:ext cx="5120640" cy="1737360"/>
-          </a:xfrm>
-          <a:prstGeom prst="roundRect">
-            <a:avLst>
-              <a:gd name="adj" fmla="val 4737"/>
-            </a:avLst>
-          </a:prstGeom>
-          <a:solidFill>
-            <a:srgbClr val="F4F6F4"/>
-          </a:solidFill>
-          <a:ln w="12700">
-            <a:solidFill>
-              <a:srgbClr val="E2E4E0"/>
-            </a:solidFill>
-            <a:prstDash val="solid"/>
-          </a:ln>
-        </p:spPr>
-      </p:sp>
-      <p:sp>
-        <p:nvSpPr>
-          <p:cNvPr id="11" name="Text 9"/>
-          <p:cNvSpPr/>
-          <p:nvPr/>
-        </p:nvSpPr>
-        <p:spPr>
-          <a:xfrm>
-            <a:off x="1188720" y="4800600"/>
-            <a:ext cx="4389120" cy="457200"/>
-          </a:xfrm>
-          <a:prstGeom prst="rect">
-            <a:avLst/>
-          </a:prstGeom>
-          <a:noFill/>
-          <a:ln/>
-        </p:spPr>
-        <p:txBody>
-          <a:bodyPr wrap="square" rtlCol="0" anchor="ctr"/>
-          <a:lstStyle/>
-          <a:p>
-            <a:pPr indent="0" marL="0">
-              <a:buNone/>
-            </a:pPr>
-            <a:r>
-              <a:rPr lang="en-US" sz="1700" b="1" dirty="0">
-                <a:solidFill>
-                  <a:srgbClr val="16513C"/>
-                </a:solidFill>
-                <a:latin typeface="Arial" pitchFamily="34" charset="0"/>
-                <a:ea typeface="Arial" pitchFamily="34" charset="-122"/>
-                <a:cs typeface="Arial" pitchFamily="34" charset="-120"/>
-              </a:rPr>
-              <a:t>Keep the enquiry form</a:t>
-            </a:r>
-            <a:endParaRPr lang="en-US" sz="1700" dirty="0"/>
-          </a:p>
-        </p:txBody>
-      </p:sp>
-      <p:sp>
-        <p:nvSpPr>
-          <p:cNvPr id="12" name="Text 10"/>
-          <p:cNvSpPr/>
-          <p:nvPr/>
-        </p:nvSpPr>
-        <p:spPr>
-          <a:xfrm>
-            <a:off x="1188720" y="5303520"/>
-            <a:ext cx="4389120" cy="777240"/>
-          </a:xfrm>
-          <a:prstGeom prst="rect">
-            <a:avLst/>
-          </a:prstGeom>
-          <a:noFill/>
-          <a:ln/>
-        </p:spPr>
-        <p:txBody>
-          <a:bodyPr wrap="square" rtlCol="0" anchor="ctr"/>
-          <a:lstStyle/>
-          <a:p>
-            <a:pPr indent="0" marL="0">
-              <a:lnSpc>
-                <a:spcPts val="1800"/>
-              </a:lnSpc>
-              <a:buNone/>
-            </a:pPr>
-            <a:r>
-              <a:rPr lang="en-US" sz="1300" dirty="0">
-                <a:solidFill>
-                  <a:srgbClr val="5A6661"/>
-                </a:solidFill>
-                <a:latin typeface="Arial" pitchFamily="34" charset="0"/>
-                <a:ea typeface="Arial" pitchFamily="34" charset="-122"/>
-                <a:cs typeface="Arial" pitchFamily="34" charset="-120"/>
-              </a:rPr>
-              <a:t>Questions still go to the form; bookings go to the calendar.</a:t>
-            </a:r>
-            <a:endParaRPr lang="en-US" sz="1300" dirty="0"/>
-          </a:p>
-        </p:txBody>
-      </p:sp>
-      <p:sp>
-        <p:nvSpPr>
-          <p:cNvPr id="13" name="Shape 11"/>
-          <p:cNvSpPr/>
-          <p:nvPr/>
-        </p:nvSpPr>
-        <p:spPr>
-          <a:xfrm>
-            <a:off x="6355080" y="4526280"/>
-            <a:ext cx="5120640" cy="1737360"/>
-          </a:xfrm>
-          <a:prstGeom prst="roundRect">
-            <a:avLst>
-              <a:gd name="adj" fmla="val 4737"/>
-            </a:avLst>
-          </a:prstGeom>
-          <a:solidFill>
-            <a:srgbClr val="F4F6F4"/>
-          </a:solidFill>
-          <a:ln w="12700">
-            <a:solidFill>
-              <a:srgbClr val="E2E4E0"/>
-            </a:solidFill>
-            <a:prstDash val="solid"/>
-          </a:ln>
-        </p:spPr>
-      </p:sp>
-      <p:sp>
-        <p:nvSpPr>
-          <p:cNvPr id="14" name="Text 12"/>
-          <p:cNvSpPr/>
-          <p:nvPr/>
-        </p:nvSpPr>
-        <p:spPr>
-          <a:xfrm>
-            <a:off x="6720840" y="4800600"/>
-            <a:ext cx="4389120" cy="457200"/>
-          </a:xfrm>
-          <a:prstGeom prst="rect">
-            <a:avLst/>
-          </a:prstGeom>
-          <a:noFill/>
-          <a:ln/>
-        </p:spPr>
-        <p:txBody>
-          <a:bodyPr wrap="square" rtlCol="0" anchor="ctr"/>
-          <a:lstStyle/>
-          <a:p>
-            <a:pPr indent="0" marL="0">
-              <a:buNone/>
-            </a:pPr>
-            <a:r>
-              <a:rPr lang="en-US" sz="1700" b="1" dirty="0">
-                <a:solidFill>
-                  <a:srgbClr val="16513C"/>
-                </a:solidFill>
-                <a:latin typeface="Arial" pitchFamily="34" charset="0"/>
-                <a:ea typeface="Arial" pitchFamily="34" charset="-122"/>
-                <a:cs typeface="Arial" pitchFamily="34" charset="-120"/>
-              </a:rPr>
-              <a:t>Promote in follow-ups</a:t>
-            </a:r>
-            <a:endParaRPr lang="en-US" sz="1700" dirty="0"/>
-          </a:p>
-        </p:txBody>
-      </p:sp>
-      <p:sp>
-        <p:nvSpPr>
-          <p:cNvPr id="15" name="Text 13"/>
-          <p:cNvSpPr/>
-          <p:nvPr/>
-        </p:nvSpPr>
-        <p:spPr>
-          <a:xfrm>
-            <a:off x="6720840" y="5303520"/>
-            <a:ext cx="4389120" cy="777240"/>
-          </a:xfrm>
-          <a:prstGeom prst="rect">
-            <a:avLst/>
-          </a:prstGeom>
-          <a:noFill/>
-          <a:ln/>
-        </p:spPr>
-        <p:txBody>
-          <a:bodyPr wrap="square" rtlCol="0" anchor="ctr"/>
-          <a:lstStyle/>
-          <a:p>
-            <a:pPr indent="0" marL="0">
-              <a:lnSpc>
-                <a:spcPts val="1800"/>
-              </a:lnSpc>
-              <a:buNone/>
-            </a:pPr>
-            <a:r>
-              <a:rPr lang="en-US" sz="1300" dirty="0">
-                <a:solidFill>
-                  <a:srgbClr val="5A6661"/>
-                </a:solidFill>
-                <a:latin typeface="Arial" pitchFamily="34" charset="0"/>
-                <a:ea typeface="Arial" pitchFamily="34" charset="-122"/>
-                <a:cs typeface="Arial" pitchFamily="34" charset="-120"/>
-              </a:rPr>
-              <a:t>Drop the booking link in quotes and after-visit emails.</a:t>
-            </a:r>
-            <a:endParaRPr lang="en-US" sz="1300" dirty="0"/>
-          </a:p>
-        </p:txBody>
-      </p:sp>
-    </p:spTree>
-  </p:cSld>
-  <p:clrMapOvr>
-    <a:masterClrMapping/>
-  </p:clrMapOvr>
-</p:sld>
-</file>
-
-<file path=ppt/slides/slide11.xml><?xml version="1.0" encoding="utf-8"?>
-<p:sld xmlns:a="http://schemas.openxmlformats.org/drawingml/2006/main" xmlns:r="http://schemas.openxmlformats.org/officeDocument/2006/relationships" xmlns:p="http://schemas.openxmlformats.org/presentationml/2006/main">
-  <p:cSld name="Slide 11">
-    <p:bg>
-      <p:bgPr>
-        <a:solidFill>
           <a:srgbClr val="16201C"/>
         </a:solidFill>
       </p:bgPr>
@@ -3376,9 +2742,9 @@
 </p:sld>
 </file>
 
-<file path=ppt/slides/slide12.xml><?xml version="1.0" encoding="utf-8"?>
+<file path=ppt/slides/slide11.xml><?xml version="1.0" encoding="utf-8"?>
 <p:sld xmlns:a="http://schemas.openxmlformats.org/drawingml/2006/main" xmlns:r="http://schemas.openxmlformats.org/officeDocument/2006/relationships" xmlns:p="http://schemas.openxmlformats.org/presentationml/2006/main">
-  <p:cSld name="Slide 12">
+  <p:cSld name="Slide 11">
     <p:bg>
       <p:bgPr>
         <a:solidFill>
@@ -7057,6 +6423,784 @@
     <p:bg>
       <p:bgPr>
         <a:solidFill>
+          <a:srgbClr val="16201C"/>
+        </a:solidFill>
+      </p:bgPr>
+    </p:bg>
+    <p:spTree>
+      <p:nvGrpSpPr>
+        <p:cNvPr id="1" name=""/>
+        <p:cNvGrpSpPr/>
+        <p:nvPr/>
+      </p:nvGrpSpPr>
+      <p:grpSpPr>
+        <a:xfrm>
+          <a:off x="0" y="0"/>
+          <a:ext cx="0" cy="0"/>
+          <a:chOff x="0" y="0"/>
+          <a:chExt cx="0" cy="0"/>
+        </a:xfrm>
+      </p:grpSpPr>
+      <p:sp>
+        <p:nvSpPr>
+          <p:cNvPr id="2" name="Text 0"/>
+          <p:cNvSpPr/>
+          <p:nvPr/>
+        </p:nvSpPr>
+        <p:spPr>
+          <a:xfrm>
+            <a:off x="822960" y="640080"/>
+            <a:ext cx="8229600" cy="292608"/>
+          </a:xfrm>
+          <a:prstGeom prst="rect">
+            <a:avLst/>
+          </a:prstGeom>
+          <a:noFill/>
+          <a:ln/>
+        </p:spPr>
+        <p:txBody>
+          <a:bodyPr wrap="square" rtlCol="0" anchor="ctr"/>
+          <a:lstStyle/>
+          <a:p>
+            <a:pPr algn="l" indent="0" marL="0">
+              <a:buNone/>
+            </a:pPr>
+            <a:r>
+              <a:rPr lang="en-US" sz="1250" b="1" spc="300" kern="0" dirty="0">
+                <a:solidFill>
+                  <a:srgbClr val="4FA98A"/>
+                </a:solidFill>
+                <a:latin typeface="Courier New" pitchFamily="34" charset="0"/>
+                <a:ea typeface="Courier New" pitchFamily="34" charset="-122"/>
+                <a:cs typeface="Courier New" pitchFamily="34" charset="-120"/>
+              </a:rPr>
+              <a:t>WHAT YOU GET</a:t>
+            </a:r>
+            <a:endParaRPr lang="en-US" sz="1250" dirty="0"/>
+          </a:p>
+        </p:txBody>
+      </p:sp>
+      <p:sp>
+        <p:nvSpPr>
+          <p:cNvPr id="3" name="Text 1"/>
+          <p:cNvSpPr/>
+          <p:nvPr/>
+        </p:nvSpPr>
+        <p:spPr>
+          <a:xfrm>
+            <a:off x="822960" y="960120"/>
+            <a:ext cx="10607040" cy="914400"/>
+          </a:xfrm>
+          <a:prstGeom prst="rect">
+            <a:avLst/>
+          </a:prstGeom>
+          <a:noFill/>
+          <a:ln/>
+        </p:spPr>
+        <p:txBody>
+          <a:bodyPr wrap="square" rtlCol="0" anchor="ctr"/>
+          <a:lstStyle/>
+          <a:p>
+            <a:pPr indent="0" marL="0">
+              <a:buNone/>
+            </a:pPr>
+            <a:r>
+              <a:rPr lang="en-US" sz="3400" b="1" dirty="0">
+                <a:solidFill>
+                  <a:srgbClr val="FFFFFF"/>
+                </a:solidFill>
+                <a:latin typeface="Arial" pitchFamily="34" charset="0"/>
+                <a:ea typeface="Arial" pitchFamily="34" charset="-122"/>
+                <a:cs typeface="Arial" pitchFamily="34" charset="-120"/>
+              </a:rPr>
+              <a:t>Value to outdoor.ie</a:t>
+            </a:r>
+            <a:endParaRPr lang="en-US" sz="3400" dirty="0"/>
+          </a:p>
+        </p:txBody>
+      </p:sp>
+      <p:sp>
+        <p:nvSpPr>
+          <p:cNvPr id="4" name="Shape 2"/>
+          <p:cNvSpPr/>
+          <p:nvPr/>
+        </p:nvSpPr>
+        <p:spPr>
+          <a:xfrm>
+            <a:off x="822960" y="2468880"/>
+            <a:ext cx="5120640" cy="1737360"/>
+          </a:xfrm>
+          <a:prstGeom prst="roundRect">
+            <a:avLst>
+              <a:gd name="adj" fmla="val 4737"/>
+            </a:avLst>
+          </a:prstGeom>
+          <a:solidFill>
+            <a:srgbClr val="22302A"/>
+          </a:solidFill>
+          <a:ln w="12700">
+            <a:solidFill>
+              <a:srgbClr val="36473E"/>
+            </a:solidFill>
+            <a:prstDash val="solid"/>
+          </a:ln>
+        </p:spPr>
+      </p:sp>
+      <p:sp>
+        <p:nvSpPr>
+          <p:cNvPr id="5" name="Shape 3"/>
+          <p:cNvSpPr/>
+          <p:nvPr/>
+        </p:nvSpPr>
+        <p:spPr>
+          <a:xfrm>
+            <a:off x="1143000" y="2788920"/>
+            <a:ext cx="457200" cy="457200"/>
+          </a:xfrm>
+          <a:prstGeom prst="ellipse">
+            <a:avLst/>
+          </a:prstGeom>
+          <a:solidFill>
+            <a:srgbClr val="16513C"/>
+          </a:solidFill>
+          <a:ln/>
+        </p:spPr>
+      </p:sp>
+      <p:sp>
+        <p:nvSpPr>
+          <p:cNvPr id="6" name="Text 4"/>
+          <p:cNvSpPr/>
+          <p:nvPr/>
+        </p:nvSpPr>
+        <p:spPr>
+          <a:xfrm>
+            <a:off x="1143000" y="2788920"/>
+            <a:ext cx="457200" cy="457200"/>
+          </a:xfrm>
+          <a:prstGeom prst="rect">
+            <a:avLst/>
+          </a:prstGeom>
+          <a:noFill/>
+          <a:ln/>
+        </p:spPr>
+        <p:txBody>
+          <a:bodyPr wrap="square" rtlCol="0" anchor="ctr"/>
+          <a:lstStyle/>
+          <a:p>
+            <a:pPr algn="ctr" indent="0" marL="0">
+              <a:buNone/>
+            </a:pPr>
+            <a:r>
+              <a:rPr lang="en-US" sz="1600" b="1" dirty="0">
+                <a:solidFill>
+                  <a:srgbClr val="FFFFFF"/>
+                </a:solidFill>
+                <a:latin typeface="Courier New" pitchFamily="34" charset="0"/>
+                <a:ea typeface="Courier New" pitchFamily="34" charset="-122"/>
+                <a:cs typeface="Courier New" pitchFamily="34" charset="-120"/>
+              </a:rPr>
+              <a:t>✓</a:t>
+            </a:r>
+            <a:endParaRPr lang="en-US" sz="1600" dirty="0"/>
+          </a:p>
+        </p:txBody>
+      </p:sp>
+      <p:sp>
+        <p:nvSpPr>
+          <p:cNvPr id="7" name="Text 5"/>
+          <p:cNvSpPr/>
+          <p:nvPr/>
+        </p:nvSpPr>
+        <p:spPr>
+          <a:xfrm>
+            <a:off x="1737360" y="2743200"/>
+            <a:ext cx="3931920" cy="457200"/>
+          </a:xfrm>
+          <a:prstGeom prst="rect">
+            <a:avLst/>
+          </a:prstGeom>
+          <a:noFill/>
+          <a:ln/>
+        </p:spPr>
+        <p:txBody>
+          <a:bodyPr wrap="square" rtlCol="0" anchor="ctr"/>
+          <a:lstStyle/>
+          <a:p>
+            <a:pPr indent="0" marL="0">
+              <a:buNone/>
+            </a:pPr>
+            <a:r>
+              <a:rPr lang="en-US" sz="1700" b="1" dirty="0">
+                <a:solidFill>
+                  <a:srgbClr val="FFFFFF"/>
+                </a:solidFill>
+                <a:latin typeface="Arial" pitchFamily="34" charset="0"/>
+                <a:ea typeface="Arial" pitchFamily="34" charset="-122"/>
+                <a:cs typeface="Arial" pitchFamily="34" charset="-120"/>
+              </a:rPr>
+              <a:t>24/7 capture</a:t>
+            </a:r>
+            <a:endParaRPr lang="en-US" sz="1700" dirty="0"/>
+          </a:p>
+        </p:txBody>
+      </p:sp>
+      <p:sp>
+        <p:nvSpPr>
+          <p:cNvPr id="8" name="Text 6"/>
+          <p:cNvSpPr/>
+          <p:nvPr/>
+        </p:nvSpPr>
+        <p:spPr>
+          <a:xfrm>
+            <a:off x="1737360" y="3246120"/>
+            <a:ext cx="3931920" cy="777240"/>
+          </a:xfrm>
+          <a:prstGeom prst="rect">
+            <a:avLst/>
+          </a:prstGeom>
+          <a:noFill/>
+          <a:ln/>
+        </p:spPr>
+        <p:txBody>
+          <a:bodyPr wrap="square" rtlCol="0" anchor="ctr"/>
+          <a:lstStyle/>
+          <a:p>
+            <a:pPr indent="0" marL="0">
+              <a:lnSpc>
+                <a:spcPts val="1700"/>
+              </a:lnSpc>
+              <a:buNone/>
+            </a:pPr>
+            <a:r>
+              <a:rPr lang="en-US" sz="1300" dirty="0">
+                <a:solidFill>
+                  <a:srgbClr val="C9D4CF"/>
+                </a:solidFill>
+                <a:latin typeface="Arial" pitchFamily="34" charset="0"/>
+                <a:ea typeface="Arial" pitchFamily="34" charset="-122"/>
+                <a:cs typeface="Arial" pitchFamily="34" charset="-120"/>
+              </a:rPr>
+              <a:t>Warm leads book themselves, even outside office hours.</a:t>
+            </a:r>
+            <a:endParaRPr lang="en-US" sz="1300" dirty="0"/>
+          </a:p>
+        </p:txBody>
+      </p:sp>
+      <p:sp>
+        <p:nvSpPr>
+          <p:cNvPr id="9" name="Shape 7"/>
+          <p:cNvSpPr/>
+          <p:nvPr/>
+        </p:nvSpPr>
+        <p:spPr>
+          <a:xfrm>
+            <a:off x="6355080" y="2468880"/>
+            <a:ext cx="5120640" cy="1737360"/>
+          </a:xfrm>
+          <a:prstGeom prst="roundRect">
+            <a:avLst>
+              <a:gd name="adj" fmla="val 4737"/>
+            </a:avLst>
+          </a:prstGeom>
+          <a:solidFill>
+            <a:srgbClr val="22302A"/>
+          </a:solidFill>
+          <a:ln w="12700">
+            <a:solidFill>
+              <a:srgbClr val="36473E"/>
+            </a:solidFill>
+            <a:prstDash val="solid"/>
+          </a:ln>
+        </p:spPr>
+      </p:sp>
+      <p:sp>
+        <p:nvSpPr>
+          <p:cNvPr id="10" name="Shape 8"/>
+          <p:cNvSpPr/>
+          <p:nvPr/>
+        </p:nvSpPr>
+        <p:spPr>
+          <a:xfrm>
+            <a:off x="6675120" y="2788920"/>
+            <a:ext cx="457200" cy="457200"/>
+          </a:xfrm>
+          <a:prstGeom prst="ellipse">
+            <a:avLst/>
+          </a:prstGeom>
+          <a:solidFill>
+            <a:srgbClr val="16513C"/>
+          </a:solidFill>
+          <a:ln/>
+        </p:spPr>
+      </p:sp>
+      <p:sp>
+        <p:nvSpPr>
+          <p:cNvPr id="11" name="Text 9"/>
+          <p:cNvSpPr/>
+          <p:nvPr/>
+        </p:nvSpPr>
+        <p:spPr>
+          <a:xfrm>
+            <a:off x="6675120" y="2788920"/>
+            <a:ext cx="457200" cy="457200"/>
+          </a:xfrm>
+          <a:prstGeom prst="rect">
+            <a:avLst/>
+          </a:prstGeom>
+          <a:noFill/>
+          <a:ln/>
+        </p:spPr>
+        <p:txBody>
+          <a:bodyPr wrap="square" rtlCol="0" anchor="ctr"/>
+          <a:lstStyle/>
+          <a:p>
+            <a:pPr algn="ctr" indent="0" marL="0">
+              <a:buNone/>
+            </a:pPr>
+            <a:r>
+              <a:rPr lang="en-US" sz="1600" b="1" dirty="0">
+                <a:solidFill>
+                  <a:srgbClr val="FFFFFF"/>
+                </a:solidFill>
+                <a:latin typeface="Courier New" pitchFamily="34" charset="0"/>
+                <a:ea typeface="Courier New" pitchFamily="34" charset="-122"/>
+                <a:cs typeface="Courier New" pitchFamily="34" charset="-120"/>
+              </a:rPr>
+              <a:t>✓</a:t>
+            </a:r>
+            <a:endParaRPr lang="en-US" sz="1600" dirty="0"/>
+          </a:p>
+        </p:txBody>
+      </p:sp>
+      <p:sp>
+        <p:nvSpPr>
+          <p:cNvPr id="12" name="Text 10"/>
+          <p:cNvSpPr/>
+          <p:nvPr/>
+        </p:nvSpPr>
+        <p:spPr>
+          <a:xfrm>
+            <a:off x="7269480" y="2743200"/>
+            <a:ext cx="3931920" cy="457200"/>
+          </a:xfrm>
+          <a:prstGeom prst="rect">
+            <a:avLst/>
+          </a:prstGeom>
+          <a:noFill/>
+          <a:ln/>
+        </p:spPr>
+        <p:txBody>
+          <a:bodyPr wrap="square" rtlCol="0" anchor="ctr"/>
+          <a:lstStyle/>
+          <a:p>
+            <a:pPr indent="0" marL="0">
+              <a:buNone/>
+            </a:pPr>
+            <a:r>
+              <a:rPr lang="en-US" sz="1700" b="1" dirty="0">
+                <a:solidFill>
+                  <a:srgbClr val="FFFFFF"/>
+                </a:solidFill>
+                <a:latin typeface="Arial" pitchFamily="34" charset="0"/>
+                <a:ea typeface="Arial" pitchFamily="34" charset="-122"/>
+                <a:cs typeface="Arial" pitchFamily="34" charset="-120"/>
+              </a:rPr>
+              <a:t>Zero scheduling time</a:t>
+            </a:r>
+            <a:endParaRPr lang="en-US" sz="1700" dirty="0"/>
+          </a:p>
+        </p:txBody>
+      </p:sp>
+      <p:sp>
+        <p:nvSpPr>
+          <p:cNvPr id="13" name="Text 11"/>
+          <p:cNvSpPr/>
+          <p:nvPr/>
+        </p:nvSpPr>
+        <p:spPr>
+          <a:xfrm>
+            <a:off x="7269480" y="3246120"/>
+            <a:ext cx="3931920" cy="777240"/>
+          </a:xfrm>
+          <a:prstGeom prst="rect">
+            <a:avLst/>
+          </a:prstGeom>
+          <a:noFill/>
+          <a:ln/>
+        </p:spPr>
+        <p:txBody>
+          <a:bodyPr wrap="square" rtlCol="0" anchor="ctr"/>
+          <a:lstStyle/>
+          <a:p>
+            <a:pPr indent="0" marL="0">
+              <a:lnSpc>
+                <a:spcPts val="1700"/>
+              </a:lnSpc>
+              <a:buNone/>
+            </a:pPr>
+            <a:r>
+              <a:rPr lang="en-US" sz="1300" dirty="0">
+                <a:solidFill>
+                  <a:srgbClr val="C9D4CF"/>
+                </a:solidFill>
+                <a:latin typeface="Arial" pitchFamily="34" charset="0"/>
+                <a:ea typeface="Arial" pitchFamily="34" charset="-122"/>
+                <a:cs typeface="Arial" pitchFamily="34" charset="-120"/>
+              </a:rPr>
+              <a:t>No one manually arranges or chases consultations.</a:t>
+            </a:r>
+            <a:endParaRPr lang="en-US" sz="1300" dirty="0"/>
+          </a:p>
+        </p:txBody>
+      </p:sp>
+      <p:sp>
+        <p:nvSpPr>
+          <p:cNvPr id="14" name="Shape 12"/>
+          <p:cNvSpPr/>
+          <p:nvPr/>
+        </p:nvSpPr>
+        <p:spPr>
+          <a:xfrm>
+            <a:off x="822960" y="4480560"/>
+            <a:ext cx="5120640" cy="1737360"/>
+          </a:xfrm>
+          <a:prstGeom prst="roundRect">
+            <a:avLst>
+              <a:gd name="adj" fmla="val 4737"/>
+            </a:avLst>
+          </a:prstGeom>
+          <a:solidFill>
+            <a:srgbClr val="22302A"/>
+          </a:solidFill>
+          <a:ln w="12700">
+            <a:solidFill>
+              <a:srgbClr val="36473E"/>
+            </a:solidFill>
+            <a:prstDash val="solid"/>
+          </a:ln>
+        </p:spPr>
+      </p:sp>
+      <p:sp>
+        <p:nvSpPr>
+          <p:cNvPr id="15" name="Shape 13"/>
+          <p:cNvSpPr/>
+          <p:nvPr/>
+        </p:nvSpPr>
+        <p:spPr>
+          <a:xfrm>
+            <a:off x="1143000" y="4800600"/>
+            <a:ext cx="457200" cy="457200"/>
+          </a:xfrm>
+          <a:prstGeom prst="ellipse">
+            <a:avLst/>
+          </a:prstGeom>
+          <a:solidFill>
+            <a:srgbClr val="16513C"/>
+          </a:solidFill>
+          <a:ln/>
+        </p:spPr>
+      </p:sp>
+      <p:sp>
+        <p:nvSpPr>
+          <p:cNvPr id="16" name="Text 14"/>
+          <p:cNvSpPr/>
+          <p:nvPr/>
+        </p:nvSpPr>
+        <p:spPr>
+          <a:xfrm>
+            <a:off x="1143000" y="4800600"/>
+            <a:ext cx="457200" cy="457200"/>
+          </a:xfrm>
+          <a:prstGeom prst="rect">
+            <a:avLst/>
+          </a:prstGeom>
+          <a:noFill/>
+          <a:ln/>
+        </p:spPr>
+        <p:txBody>
+          <a:bodyPr wrap="square" rtlCol="0" anchor="ctr"/>
+          <a:lstStyle/>
+          <a:p>
+            <a:pPr algn="ctr" indent="0" marL="0">
+              <a:buNone/>
+            </a:pPr>
+            <a:r>
+              <a:rPr lang="en-US" sz="1600" b="1" dirty="0">
+                <a:solidFill>
+                  <a:srgbClr val="FFFFFF"/>
+                </a:solidFill>
+                <a:latin typeface="Courier New" pitchFamily="34" charset="0"/>
+                <a:ea typeface="Courier New" pitchFamily="34" charset="-122"/>
+                <a:cs typeface="Courier New" pitchFamily="34" charset="-120"/>
+              </a:rPr>
+              <a:t>✓</a:t>
+            </a:r>
+            <a:endParaRPr lang="en-US" sz="1600" dirty="0"/>
+          </a:p>
+        </p:txBody>
+      </p:sp>
+      <p:sp>
+        <p:nvSpPr>
+          <p:cNvPr id="17" name="Text 15"/>
+          <p:cNvSpPr/>
+          <p:nvPr/>
+        </p:nvSpPr>
+        <p:spPr>
+          <a:xfrm>
+            <a:off x="1737360" y="4754880"/>
+            <a:ext cx="3931920" cy="457200"/>
+          </a:xfrm>
+          <a:prstGeom prst="rect">
+            <a:avLst/>
+          </a:prstGeom>
+          <a:noFill/>
+          <a:ln/>
+        </p:spPr>
+        <p:txBody>
+          <a:bodyPr wrap="square" rtlCol="0" anchor="ctr"/>
+          <a:lstStyle/>
+          <a:p>
+            <a:pPr indent="0" marL="0">
+              <a:buNone/>
+            </a:pPr>
+            <a:r>
+              <a:rPr lang="en-US" sz="1700" b="1" dirty="0">
+                <a:solidFill>
+                  <a:srgbClr val="FFFFFF"/>
+                </a:solidFill>
+                <a:latin typeface="Arial" pitchFamily="34" charset="0"/>
+                <a:ea typeface="Arial" pitchFamily="34" charset="-122"/>
+                <a:cs typeface="Arial" pitchFamily="34" charset="-120"/>
+              </a:rPr>
+              <a:t>Runs on what you have</a:t>
+            </a:r>
+            <a:endParaRPr lang="en-US" sz="1700" dirty="0"/>
+          </a:p>
+        </p:txBody>
+      </p:sp>
+      <p:sp>
+        <p:nvSpPr>
+          <p:cNvPr id="18" name="Text 16"/>
+          <p:cNvSpPr/>
+          <p:nvPr/>
+        </p:nvSpPr>
+        <p:spPr>
+          <a:xfrm>
+            <a:off x="1737360" y="5257800"/>
+            <a:ext cx="3931920" cy="777240"/>
+          </a:xfrm>
+          <a:prstGeom prst="rect">
+            <a:avLst/>
+          </a:prstGeom>
+          <a:noFill/>
+          <a:ln/>
+        </p:spPr>
+        <p:txBody>
+          <a:bodyPr wrap="square" rtlCol="0" anchor="ctr"/>
+          <a:lstStyle/>
+          <a:p>
+            <a:pPr indent="0" marL="0">
+              <a:lnSpc>
+                <a:spcPts val="1700"/>
+              </a:lnSpc>
+              <a:buNone/>
+            </a:pPr>
+            <a:r>
+              <a:rPr lang="en-US" sz="1300" dirty="0">
+                <a:solidFill>
+                  <a:srgbClr val="C9D4CF"/>
+                </a:solidFill>
+                <a:latin typeface="Arial" pitchFamily="34" charset="0"/>
+                <a:ea typeface="Arial" pitchFamily="34" charset="-122"/>
+                <a:cs typeface="Arial" pitchFamily="34" charset="-120"/>
+              </a:rPr>
+              <a:t>Sits on your existing WordPress site. No new platform.</a:t>
+            </a:r>
+            <a:endParaRPr lang="en-US" sz="1300" dirty="0"/>
+          </a:p>
+        </p:txBody>
+      </p:sp>
+      <p:sp>
+        <p:nvSpPr>
+          <p:cNvPr id="19" name="Shape 17"/>
+          <p:cNvSpPr/>
+          <p:nvPr/>
+        </p:nvSpPr>
+        <p:spPr>
+          <a:xfrm>
+            <a:off x="6355080" y="4480560"/>
+            <a:ext cx="5120640" cy="1737360"/>
+          </a:xfrm>
+          <a:prstGeom prst="roundRect">
+            <a:avLst>
+              <a:gd name="adj" fmla="val 4737"/>
+            </a:avLst>
+          </a:prstGeom>
+          <a:solidFill>
+            <a:srgbClr val="22302A"/>
+          </a:solidFill>
+          <a:ln w="12700">
+            <a:solidFill>
+              <a:srgbClr val="36473E"/>
+            </a:solidFill>
+            <a:prstDash val="solid"/>
+          </a:ln>
+        </p:spPr>
+      </p:sp>
+      <p:sp>
+        <p:nvSpPr>
+          <p:cNvPr id="20" name="Shape 18"/>
+          <p:cNvSpPr/>
+          <p:nvPr/>
+        </p:nvSpPr>
+        <p:spPr>
+          <a:xfrm>
+            <a:off x="6675120" y="4800600"/>
+            <a:ext cx="457200" cy="457200"/>
+          </a:xfrm>
+          <a:prstGeom prst="ellipse">
+            <a:avLst/>
+          </a:prstGeom>
+          <a:solidFill>
+            <a:srgbClr val="16513C"/>
+          </a:solidFill>
+          <a:ln/>
+        </p:spPr>
+      </p:sp>
+      <p:sp>
+        <p:nvSpPr>
+          <p:cNvPr id="21" name="Text 19"/>
+          <p:cNvSpPr/>
+          <p:nvPr/>
+        </p:nvSpPr>
+        <p:spPr>
+          <a:xfrm>
+            <a:off x="6675120" y="4800600"/>
+            <a:ext cx="457200" cy="457200"/>
+          </a:xfrm>
+          <a:prstGeom prst="rect">
+            <a:avLst/>
+          </a:prstGeom>
+          <a:noFill/>
+          <a:ln/>
+        </p:spPr>
+        <p:txBody>
+          <a:bodyPr wrap="square" rtlCol="0" anchor="ctr"/>
+          <a:lstStyle/>
+          <a:p>
+            <a:pPr algn="ctr" indent="0" marL="0">
+              <a:buNone/>
+            </a:pPr>
+            <a:r>
+              <a:rPr lang="en-US" sz="1600" b="1" dirty="0">
+                <a:solidFill>
+                  <a:srgbClr val="FFFFFF"/>
+                </a:solidFill>
+                <a:latin typeface="Courier New" pitchFamily="34" charset="0"/>
+                <a:ea typeface="Courier New" pitchFamily="34" charset="-122"/>
+                <a:cs typeface="Courier New" pitchFamily="34" charset="-120"/>
+              </a:rPr>
+              <a:t>✓</a:t>
+            </a:r>
+            <a:endParaRPr lang="en-US" sz="1600" dirty="0"/>
+          </a:p>
+        </p:txBody>
+      </p:sp>
+      <p:sp>
+        <p:nvSpPr>
+          <p:cNvPr id="22" name="Text 20"/>
+          <p:cNvSpPr/>
+          <p:nvPr/>
+        </p:nvSpPr>
+        <p:spPr>
+          <a:xfrm>
+            <a:off x="7269480" y="4754880"/>
+            <a:ext cx="3931920" cy="457200"/>
+          </a:xfrm>
+          <a:prstGeom prst="rect">
+            <a:avLst/>
+          </a:prstGeom>
+          <a:noFill/>
+          <a:ln/>
+        </p:spPr>
+        <p:txBody>
+          <a:bodyPr wrap="square" rtlCol="0" anchor="ctr"/>
+          <a:lstStyle/>
+          <a:p>
+            <a:pPr indent="0" marL="0">
+              <a:buNone/>
+            </a:pPr>
+            <a:r>
+              <a:rPr lang="en-US" sz="1700" b="1" dirty="0">
+                <a:solidFill>
+                  <a:srgbClr val="FFFFFF"/>
+                </a:solidFill>
+                <a:latin typeface="Arial" pitchFamily="34" charset="0"/>
+                <a:ea typeface="Arial" pitchFamily="34" charset="-122"/>
+                <a:cs typeface="Arial" pitchFamily="34" charset="-120"/>
+              </a:rPr>
+              <a:t>Fewer lost enquiries</a:t>
+            </a:r>
+            <a:endParaRPr lang="en-US" sz="1700" dirty="0"/>
+          </a:p>
+        </p:txBody>
+      </p:sp>
+      <p:sp>
+        <p:nvSpPr>
+          <p:cNvPr id="23" name="Text 21"/>
+          <p:cNvSpPr/>
+          <p:nvPr/>
+        </p:nvSpPr>
+        <p:spPr>
+          <a:xfrm>
+            <a:off x="7269480" y="5257800"/>
+            <a:ext cx="3931920" cy="777240"/>
+          </a:xfrm>
+          <a:prstGeom prst="rect">
+            <a:avLst/>
+          </a:prstGeom>
+          <a:noFill/>
+          <a:ln/>
+        </p:spPr>
+        <p:txBody>
+          <a:bodyPr wrap="square" rtlCol="0" anchor="ctr"/>
+          <a:lstStyle/>
+          <a:p>
+            <a:pPr indent="0" marL="0">
+              <a:lnSpc>
+                <a:spcPts val="1700"/>
+              </a:lnSpc>
+              <a:buNone/>
+            </a:pPr>
+            <a:r>
+              <a:rPr lang="en-US" sz="1300" dirty="0">
+                <a:solidFill>
+                  <a:srgbClr val="C9D4CF"/>
+                </a:solidFill>
+                <a:latin typeface="Arial" pitchFamily="34" charset="0"/>
+                <a:ea typeface="Arial" pitchFamily="34" charset="-122"/>
+                <a:cs typeface="Arial" pitchFamily="34" charset="-120"/>
+              </a:rPr>
+              <a:t>A real next step on the page instead of a dead end.</a:t>
+            </a:r>
+            <a:endParaRPr lang="en-US" sz="1300" dirty="0"/>
+          </a:p>
+        </p:txBody>
+      </p:sp>
+    </p:spTree>
+  </p:cSld>
+  <p:clrMapOvr>
+    <a:masterClrMapping/>
+  </p:clrMapOvr>
+</p:sld>
+</file>
+
+<file path=ppt/slides/slide8.xml><?xml version="1.0" encoding="utf-8"?>
+<p:sld xmlns:a="http://schemas.openxmlformats.org/drawingml/2006/main" xmlns:r="http://schemas.openxmlformats.org/officeDocument/2006/relationships" xmlns:p="http://schemas.openxmlformats.org/presentationml/2006/main">
+  <p:cSld name="Slide 8">
+    <p:bg>
+      <p:bgPr>
+        <a:solidFill>
           <a:srgbClr val="FFFFFF"/>
         </a:solidFill>
       </p:bgPr>
@@ -7108,7 +7252,7 @@
                 <a:ea typeface="Courier New" pitchFamily="34" charset="-122"/>
                 <a:cs typeface="Courier New" pitchFamily="34" charset="-120"/>
               </a:rPr>
-              <a:t>INVESTMENT</a:t>
+              <a:t>ROADMAP</a:t>
             </a:r>
             <a:endParaRPr lang="en-US" sz="1250" dirty="0"/>
           </a:p>
@@ -7150,7 +7294,7 @@
                 <a:ea typeface="Arial" pitchFamily="34" charset="-122"/>
                 <a:cs typeface="Arial" pitchFamily="34" charset="-120"/>
               </a:rPr>
-              <a:t>What it costs outdoor.ie</a:t>
+              <a:t>From preview to live</a:t>
             </a:r>
             <a:endParaRPr lang="en-US" sz="3300" dirty="0"/>
           </a:p>
@@ -7158,63 +7302,20 @@
       </p:sp>
       <p:sp>
         <p:nvSpPr>
-          <p:cNvPr id="4" name="Text 2"/>
-          <p:cNvSpPr/>
-          <p:nvPr/>
-        </p:nvSpPr>
-        <p:spPr>
-          <a:xfrm>
-            <a:off x="822960" y="1874520"/>
-            <a:ext cx="10424160" cy="457200"/>
-          </a:xfrm>
-          <a:prstGeom prst="rect">
-            <a:avLst/>
-          </a:prstGeom>
-          <a:noFill/>
-          <a:ln/>
-        </p:spPr>
-        <p:txBody>
-          <a:bodyPr wrap="square" rtlCol="0" anchor="ctr"/>
-          <a:lstStyle/>
-          <a:p>
-            <a:pPr indent="0" marL="0">
-              <a:buNone/>
-            </a:pPr>
-            <a:r>
-              <a:rPr lang="en-US" sz="1500" dirty="0">
-                <a:solidFill>
-                  <a:srgbClr val="5A6661"/>
-                </a:solidFill>
-                <a:latin typeface="Arial" pitchFamily="34" charset="0"/>
-                <a:ea typeface="Arial" pitchFamily="34" charset="-122"/>
-                <a:cs typeface="Arial" pitchFamily="34" charset="-120"/>
-              </a:rPr>
-              <a:t>Set up once, then managed by Loggdin. Specific figures confirmed in the accompanying quote.</a:t>
-            </a:r>
-            <a:endParaRPr lang="en-US" sz="1500" dirty="0"/>
-          </a:p>
-        </p:txBody>
-      </p:sp>
-      <p:sp>
-        <p:nvSpPr>
-          <p:cNvPr id="5" name="Shape 3"/>
-          <p:cNvSpPr/>
-          <p:nvPr/>
-        </p:nvSpPr>
-        <p:spPr>
-          <a:xfrm>
-            <a:off x="822960" y="2743200"/>
-            <a:ext cx="3383280" cy="2743200"/>
-          </a:xfrm>
-          <a:prstGeom prst="roundRect">
-            <a:avLst>
-              <a:gd name="adj" fmla="val 3000"/>
-            </a:avLst>
-          </a:prstGeom>
-          <a:solidFill>
-            <a:srgbClr val="F4F6F4"/>
-          </a:solidFill>
-          <a:ln w="12700">
+          <p:cNvPr id="4" name="Shape 2"/>
+          <p:cNvSpPr/>
+          <p:nvPr/>
+        </p:nvSpPr>
+        <p:spPr>
+          <a:xfrm>
+            <a:off x="1234440" y="3794760"/>
+            <a:ext cx="9692640" cy="0"/>
+          </a:xfrm>
+          <a:prstGeom prst="line">
+            <a:avLst/>
+          </a:prstGeom>
+          <a:noFill/>
+          <a:ln w="25400">
             <a:solidFill>
               <a:srgbClr val="E2E4E0"/>
             </a:solidFill>
@@ -7224,40 +7325,65 @@
       </p:sp>
       <p:sp>
         <p:nvSpPr>
+          <p:cNvPr id="5" name="Shape 3"/>
+          <p:cNvSpPr/>
+          <p:nvPr/>
+        </p:nvSpPr>
+        <p:spPr>
+          <a:xfrm>
+            <a:off x="960120" y="3520440"/>
+            <a:ext cx="548640" cy="548640"/>
+          </a:xfrm>
+          <a:prstGeom prst="ellipse">
+            <a:avLst/>
+          </a:prstGeom>
+          <a:solidFill>
+            <a:srgbClr val="16513C"/>
+          </a:solidFill>
+          <a:ln w="38100">
+            <a:solidFill>
+              <a:srgbClr val="FFFFFF"/>
+            </a:solidFill>
+            <a:prstDash val="solid"/>
+          </a:ln>
+        </p:spPr>
+      </p:sp>
+      <p:sp>
+        <p:nvSpPr>
           <p:cNvPr id="6" name="Text 4"/>
           <p:cNvSpPr/>
           <p:nvPr/>
         </p:nvSpPr>
         <p:spPr>
           <a:xfrm>
-            <a:off x="1143000" y="3017520"/>
-            <a:ext cx="2743200" cy="365760"/>
-          </a:xfrm>
-          <a:prstGeom prst="rect">
-            <a:avLst/>
-          </a:prstGeom>
-          <a:noFill/>
-          <a:ln/>
-        </p:spPr>
-        <p:txBody>
-          <a:bodyPr wrap="square" rtlCol="0" anchor="ctr"/>
-          <a:lstStyle/>
-          <a:p>
-            <a:pPr indent="0" marL="0">
-              <a:buNone/>
-            </a:pPr>
-            <a:r>
-              <a:rPr lang="en-US" sz="1300" b="1" spc="200" kern="0" dirty="0">
-                <a:solidFill>
-                  <a:srgbClr val="16513C"/>
+            <a:off x="960120" y="3520440"/>
+            <a:ext cx="548640" cy="548640"/>
+          </a:xfrm>
+          <a:prstGeom prst="rect">
+            <a:avLst/>
+          </a:prstGeom>
+          <a:noFill/>
+          <a:ln/>
+        </p:spPr>
+        <p:txBody>
+          <a:bodyPr wrap="square" rtlCol="0" anchor="ctr"/>
+          <a:lstStyle/>
+          <a:p>
+            <a:pPr algn="ctr" indent="0" marL="0">
+              <a:buNone/>
+            </a:pPr>
+            <a:r>
+              <a:rPr lang="en-US" sz="1200" b="1" dirty="0">
+                <a:solidFill>
+                  <a:srgbClr val="FFFFFF"/>
                 </a:solidFill>
                 <a:latin typeface="Courier New" pitchFamily="34" charset="0"/>
                 <a:ea typeface="Courier New" pitchFamily="34" charset="-122"/>
                 <a:cs typeface="Courier New" pitchFamily="34" charset="-120"/>
               </a:rPr>
-              <a:t>SETUP</a:t>
-            </a:r>
-            <a:endParaRPr lang="en-US" sz="1300" dirty="0"/>
+              <a:t>P1</a:t>
+            </a:r>
+            <a:endParaRPr lang="en-US" sz="1200" dirty="0"/>
           </a:p>
         </p:txBody>
       </p:sp>
@@ -7269,24 +7395,24 @@
         </p:nvSpPr>
         <p:spPr>
           <a:xfrm>
-            <a:off x="1143000" y="3429000"/>
-            <a:ext cx="2743200" cy="457200"/>
-          </a:xfrm>
-          <a:prstGeom prst="rect">
-            <a:avLst/>
-          </a:prstGeom>
-          <a:noFill/>
-          <a:ln/>
-        </p:spPr>
-        <p:txBody>
-          <a:bodyPr wrap="square" rtlCol="0" anchor="ctr"/>
-          <a:lstStyle/>
-          <a:p>
-            <a:pPr indent="0" marL="0">
-              <a:buNone/>
-            </a:pPr>
-            <a:r>
-              <a:rPr lang="en-US" sz="2000" b="1" dirty="0">
+            <a:off x="228600" y="2377440"/>
+            <a:ext cx="2011680" cy="365760"/>
+          </a:xfrm>
+          <a:prstGeom prst="rect">
+            <a:avLst/>
+          </a:prstGeom>
+          <a:noFill/>
+          <a:ln/>
+        </p:spPr>
+        <p:txBody>
+          <a:bodyPr wrap="square" rtlCol="0" anchor="ctr"/>
+          <a:lstStyle/>
+          <a:p>
+            <a:pPr algn="ctr" indent="0" marL="0">
+              <a:buNone/>
+            </a:pPr>
+            <a:r>
+              <a:rPr lang="en-US" sz="1500" b="1" dirty="0">
                 <a:solidFill>
                   <a:srgbClr val="16201C"/>
                 </a:solidFill>
@@ -7294,9 +7420,9 @@
                 <a:ea typeface="Arial" pitchFamily="34" charset="-122"/>
                 <a:cs typeface="Arial" pitchFamily="34" charset="-120"/>
               </a:rPr>
-              <a:t>One-time</a:t>
-            </a:r>
-            <a:endParaRPr lang="en-US" sz="2000" dirty="0"/>
+              <a:t>Preview</a:t>
+            </a:r>
+            <a:endParaRPr lang="en-US" sz="1500" dirty="0"/>
           </a:p>
         </p:txBody>
       </p:sp>
@@ -7308,27 +7434,27 @@
         </p:nvSpPr>
         <p:spPr>
           <a:xfrm>
-            <a:off x="1143000" y="4023360"/>
-            <a:ext cx="2743200" cy="1280160"/>
-          </a:xfrm>
-          <a:prstGeom prst="rect">
-            <a:avLst/>
-          </a:prstGeom>
-          <a:noFill/>
-          <a:ln/>
-        </p:spPr>
-        <p:txBody>
-          <a:bodyPr wrap="square" rtlCol="0" anchor="ctr"/>
-          <a:lstStyle/>
-          <a:p>
-            <a:pPr indent="0" marL="0">
+            <a:off x="91440" y="2743200"/>
+            <a:ext cx="2286000" cy="868680"/>
+          </a:xfrm>
+          <a:prstGeom prst="rect">
+            <a:avLst/>
+          </a:prstGeom>
+          <a:noFill/>
+          <a:ln/>
+        </p:spPr>
+        <p:txBody>
+          <a:bodyPr wrap="square" rtlCol="0" anchor="ctr"/>
+          <a:lstStyle/>
+          <a:p>
+            <a:pPr algn="ctr" indent="0" marL="0">
               <a:lnSpc>
-                <a:spcPts val="1800"/>
+                <a:spcPts val="1500"/>
               </a:lnSpc>
               <a:buNone/>
             </a:pPr>
             <a:r>
-              <a:rPr lang="en-US" sz="1300" dirty="0">
+              <a:rPr lang="en-US" sz="1200" dirty="0">
                 <a:solidFill>
                   <a:srgbClr val="5A6661"/>
                 </a:solidFill>
@@ -7336,9 +7462,9 @@
                 <a:ea typeface="Arial" pitchFamily="34" charset="-122"/>
                 <a:cs typeface="Arial" pitchFamily="34" charset="-120"/>
               </a:rPr>
-              <a:t>We build the page, wire up the Cal.com calendar, availability and branding.</a:t>
-            </a:r>
-            <a:endParaRPr lang="en-US" sz="1300" dirty="0"/>
+              <a:t>Test on a draft page, no one sees it yet.</a:t>
+            </a:r>
+            <a:endParaRPr lang="en-US" sz="1200" dirty="0"/>
           </a:p>
         </p:txBody>
       </p:sp>
@@ -7350,20 +7476,18 @@
         </p:nvSpPr>
         <p:spPr>
           <a:xfrm>
-            <a:off x="4617720" y="2743200"/>
-            <a:ext cx="3383280" cy="2743200"/>
-          </a:xfrm>
-          <a:prstGeom prst="roundRect">
-            <a:avLst>
-              <a:gd name="adj" fmla="val 3000"/>
-            </a:avLst>
+            <a:off x="3383280" y="3520440"/>
+            <a:ext cx="548640" cy="548640"/>
+          </a:xfrm>
+          <a:prstGeom prst="ellipse">
+            <a:avLst/>
           </a:prstGeom>
           <a:solidFill>
-            <a:srgbClr val="F4F6F4"/>
+            <a:srgbClr val="16513C"/>
           </a:solidFill>
-          <a:ln w="12700">
+          <a:ln w="38100">
             <a:solidFill>
-              <a:srgbClr val="E2E4E0"/>
+              <a:srgbClr val="FFFFFF"/>
             </a:solidFill>
             <a:prstDash val="solid"/>
           </a:ln>
@@ -7377,34 +7501,34 @@
         </p:nvSpPr>
         <p:spPr>
           <a:xfrm>
-            <a:off x="4937760" y="3017520"/>
-            <a:ext cx="2743200" cy="365760"/>
-          </a:xfrm>
-          <a:prstGeom prst="rect">
-            <a:avLst/>
-          </a:prstGeom>
-          <a:noFill/>
-          <a:ln/>
-        </p:spPr>
-        <p:txBody>
-          <a:bodyPr wrap="square" rtlCol="0" anchor="ctr"/>
-          <a:lstStyle/>
-          <a:p>
-            <a:pPr indent="0" marL="0">
-              <a:buNone/>
-            </a:pPr>
-            <a:r>
-              <a:rPr lang="en-US" sz="1300" b="1" spc="200" kern="0" dirty="0">
-                <a:solidFill>
-                  <a:srgbClr val="16513C"/>
+            <a:off x="3383280" y="3520440"/>
+            <a:ext cx="548640" cy="548640"/>
+          </a:xfrm>
+          <a:prstGeom prst="rect">
+            <a:avLst/>
+          </a:prstGeom>
+          <a:noFill/>
+          <a:ln/>
+        </p:spPr>
+        <p:txBody>
+          <a:bodyPr wrap="square" rtlCol="0" anchor="ctr"/>
+          <a:lstStyle/>
+          <a:p>
+            <a:pPr algn="ctr" indent="0" marL="0">
+              <a:buNone/>
+            </a:pPr>
+            <a:r>
+              <a:rPr lang="en-US" sz="1200" b="1" dirty="0">
+                <a:solidFill>
+                  <a:srgbClr val="FFFFFF"/>
                 </a:solidFill>
                 <a:latin typeface="Courier New" pitchFamily="34" charset="0"/>
                 <a:ea typeface="Courier New" pitchFamily="34" charset="-122"/>
                 <a:cs typeface="Courier New" pitchFamily="34" charset="-120"/>
               </a:rPr>
-              <a:t>ONGOING</a:t>
-            </a:r>
-            <a:endParaRPr lang="en-US" sz="1300" dirty="0"/>
+              <a:t>P2</a:t>
+            </a:r>
+            <a:endParaRPr lang="en-US" sz="1200" dirty="0"/>
           </a:p>
         </p:txBody>
       </p:sp>
@@ -7416,24 +7540,24 @@
         </p:nvSpPr>
         <p:spPr>
           <a:xfrm>
-            <a:off x="4937760" y="3429000"/>
-            <a:ext cx="2743200" cy="457200"/>
-          </a:xfrm>
-          <a:prstGeom prst="rect">
-            <a:avLst/>
-          </a:prstGeom>
-          <a:noFill/>
-          <a:ln/>
-        </p:spPr>
-        <p:txBody>
-          <a:bodyPr wrap="square" rtlCol="0" anchor="ctr"/>
-          <a:lstStyle/>
-          <a:p>
-            <a:pPr indent="0" marL="0">
-              <a:buNone/>
-            </a:pPr>
-            <a:r>
-              <a:rPr lang="en-US" sz="2000" b="1" dirty="0">
+            <a:off x="2651760" y="4251960"/>
+            <a:ext cx="2011680" cy="365760"/>
+          </a:xfrm>
+          <a:prstGeom prst="rect">
+            <a:avLst/>
+          </a:prstGeom>
+          <a:noFill/>
+          <a:ln/>
+        </p:spPr>
+        <p:txBody>
+          <a:bodyPr wrap="square" rtlCol="0" anchor="ctr"/>
+          <a:lstStyle/>
+          <a:p>
+            <a:pPr algn="ctr" indent="0" marL="0">
+              <a:buNone/>
+            </a:pPr>
+            <a:r>
+              <a:rPr lang="en-US" sz="1500" b="1" dirty="0">
                 <a:solidFill>
                   <a:srgbClr val="16201C"/>
                 </a:solidFill>
@@ -7441,9 +7565,9 @@
                 <a:ea typeface="Arial" pitchFamily="34" charset="-122"/>
                 <a:cs typeface="Arial" pitchFamily="34" charset="-120"/>
               </a:rPr>
-              <a:t>Monthly</a:t>
-            </a:r>
-            <a:endParaRPr lang="en-US" sz="2000" dirty="0"/>
+              <a:t>Cal.com setup</a:t>
+            </a:r>
+            <a:endParaRPr lang="en-US" sz="1500" dirty="0"/>
           </a:p>
         </p:txBody>
       </p:sp>
@@ -7455,27 +7579,27 @@
         </p:nvSpPr>
         <p:spPr>
           <a:xfrm>
-            <a:off x="4937760" y="4023360"/>
-            <a:ext cx="2743200" cy="1280160"/>
-          </a:xfrm>
-          <a:prstGeom prst="rect">
-            <a:avLst/>
-          </a:prstGeom>
-          <a:noFill/>
-          <a:ln/>
-        </p:spPr>
-        <p:txBody>
-          <a:bodyPr wrap="square" rtlCol="0" anchor="ctr"/>
-          <a:lstStyle/>
-          <a:p>
-            <a:pPr indent="0" marL="0">
+            <a:off x="2514600" y="4617720"/>
+            <a:ext cx="2286000" cy="868680"/>
+          </a:xfrm>
+          <a:prstGeom prst="rect">
+            <a:avLst/>
+          </a:prstGeom>
+          <a:noFill/>
+          <a:ln/>
+        </p:spPr>
+        <p:txBody>
+          <a:bodyPr wrap="square" rtlCol="0" anchor="ctr"/>
+          <a:lstStyle/>
+          <a:p>
+            <a:pPr algn="ctr" indent="0" marL="0">
               <a:lnSpc>
-                <a:spcPts val="1800"/>
+                <a:spcPts val="1500"/>
               </a:lnSpc>
               <a:buNone/>
             </a:pPr>
             <a:r>
-              <a:rPr lang="en-US" sz="1300" dirty="0">
+              <a:rPr lang="en-US" sz="1200" dirty="0">
                 <a:solidFill>
                   <a:srgbClr val="5A6661"/>
                 </a:solidFill>
@@ -7483,9 +7607,9 @@
                 <a:ea typeface="Arial" pitchFamily="34" charset="-122"/>
                 <a:cs typeface="Arial" pitchFamily="34" charset="-120"/>
               </a:rPr>
-              <a:t>We manage the calendar, handle changes to hours/holidays, and keep the embed working.</a:t>
-            </a:r>
-            <a:endParaRPr lang="en-US" sz="1300" dirty="0"/>
+              <a:t>Account, event type, availability and branding.</a:t>
+            </a:r>
+            <a:endParaRPr lang="en-US" sz="1200" dirty="0"/>
           </a:p>
         </p:txBody>
       </p:sp>
@@ -7497,20 +7621,18 @@
         </p:nvSpPr>
         <p:spPr>
           <a:xfrm>
-            <a:off x="8412480" y="2743200"/>
-            <a:ext cx="3383280" cy="2743200"/>
-          </a:xfrm>
-          <a:prstGeom prst="roundRect">
-            <a:avLst>
-              <a:gd name="adj" fmla="val 3000"/>
-            </a:avLst>
+            <a:off x="5806440" y="3520440"/>
+            <a:ext cx="548640" cy="548640"/>
+          </a:xfrm>
+          <a:prstGeom prst="ellipse">
+            <a:avLst/>
           </a:prstGeom>
           <a:solidFill>
-            <a:srgbClr val="F4F6F4"/>
+            <a:srgbClr val="16513C"/>
           </a:solidFill>
-          <a:ln w="12700">
+          <a:ln w="38100">
             <a:solidFill>
-              <a:srgbClr val="E2E4E0"/>
+              <a:srgbClr val="FFFFFF"/>
             </a:solidFill>
             <a:prstDash val="solid"/>
           </a:ln>
@@ -7524,34 +7646,34 @@
         </p:nvSpPr>
         <p:spPr>
           <a:xfrm>
-            <a:off x="8732520" y="3017520"/>
-            <a:ext cx="2743200" cy="365760"/>
-          </a:xfrm>
-          <a:prstGeom prst="rect">
-            <a:avLst/>
-          </a:prstGeom>
-          <a:noFill/>
-          <a:ln/>
-        </p:spPr>
-        <p:txBody>
-          <a:bodyPr wrap="square" rtlCol="0" anchor="ctr"/>
-          <a:lstStyle/>
-          <a:p>
-            <a:pPr indent="0" marL="0">
-              <a:buNone/>
-            </a:pPr>
-            <a:r>
-              <a:rPr lang="en-US" sz="1300" b="1" spc="200" kern="0" dirty="0">
-                <a:solidFill>
-                  <a:srgbClr val="16513C"/>
+            <a:off x="5806440" y="3520440"/>
+            <a:ext cx="548640" cy="548640"/>
+          </a:xfrm>
+          <a:prstGeom prst="rect">
+            <a:avLst/>
+          </a:prstGeom>
+          <a:noFill/>
+          <a:ln/>
+        </p:spPr>
+        <p:txBody>
+          <a:bodyPr wrap="square" rtlCol="0" anchor="ctr"/>
+          <a:lstStyle/>
+          <a:p>
+            <a:pPr algn="ctr" indent="0" marL="0">
+              <a:buNone/>
+            </a:pPr>
+            <a:r>
+              <a:rPr lang="en-US" sz="1200" b="1" dirty="0">
+                <a:solidFill>
+                  <a:srgbClr val="FFFFFF"/>
                 </a:solidFill>
                 <a:latin typeface="Courier New" pitchFamily="34" charset="0"/>
                 <a:ea typeface="Courier New" pitchFamily="34" charset="-122"/>
                 <a:cs typeface="Courier New" pitchFamily="34" charset="-120"/>
               </a:rPr>
-              <a:t>INCLUDED</a:t>
-            </a:r>
-            <a:endParaRPr lang="en-US" sz="1300" dirty="0"/>
+              <a:t>P3</a:t>
+            </a:r>
+            <a:endParaRPr lang="en-US" sz="1200" dirty="0"/>
           </a:p>
         </p:txBody>
       </p:sp>
@@ -7563,24 +7685,24 @@
         </p:nvSpPr>
         <p:spPr>
           <a:xfrm>
-            <a:off x="8732520" y="3429000"/>
-            <a:ext cx="2743200" cy="457200"/>
-          </a:xfrm>
-          <a:prstGeom prst="rect">
-            <a:avLst/>
-          </a:prstGeom>
-          <a:noFill/>
-          <a:ln/>
-        </p:spPr>
-        <p:txBody>
-          <a:bodyPr wrap="square" rtlCol="0" anchor="ctr"/>
-          <a:lstStyle/>
-          <a:p>
-            <a:pPr indent="0" marL="0">
-              <a:buNone/>
-            </a:pPr>
-            <a:r>
-              <a:rPr lang="en-US" sz="2000" b="1" dirty="0">
+            <a:off x="5074920" y="2377440"/>
+            <a:ext cx="2011680" cy="365760"/>
+          </a:xfrm>
+          <a:prstGeom prst="rect">
+            <a:avLst/>
+          </a:prstGeom>
+          <a:noFill/>
+          <a:ln/>
+        </p:spPr>
+        <p:txBody>
+          <a:bodyPr wrap="square" rtlCol="0" anchor="ctr"/>
+          <a:lstStyle/>
+          <a:p>
+            <a:pPr algn="ctr" indent="0" marL="0">
+              <a:buNone/>
+            </a:pPr>
+            <a:r>
+              <a:rPr lang="en-US" sz="1500" b="1" dirty="0">
                 <a:solidFill>
                   <a:srgbClr val="16201C"/>
                 </a:solidFill>
@@ -7588,9 +7710,9 @@
                 <a:ea typeface="Arial" pitchFamily="34" charset="-122"/>
                 <a:cs typeface="Arial" pitchFamily="34" charset="-120"/>
               </a:rPr>
-              <a:t>Always</a:t>
-            </a:r>
-            <a:endParaRPr lang="en-US" sz="2000" dirty="0"/>
+              <a:t>Go live</a:t>
+            </a:r>
+            <a:endParaRPr lang="en-US" sz="1500" dirty="0"/>
           </a:p>
         </p:txBody>
       </p:sp>
@@ -7602,27 +7724,27 @@
         </p:nvSpPr>
         <p:spPr>
           <a:xfrm>
-            <a:off x="8732520" y="4023360"/>
-            <a:ext cx="2743200" cy="1280160"/>
-          </a:xfrm>
-          <a:prstGeom prst="rect">
-            <a:avLst/>
-          </a:prstGeom>
-          <a:noFill/>
-          <a:ln/>
-        </p:spPr>
-        <p:txBody>
-          <a:bodyPr wrap="square" rtlCol="0" anchor="ctr"/>
-          <a:lstStyle/>
-          <a:p>
-            <a:pPr indent="0" marL="0">
+            <a:off x="4937760" y="2743200"/>
+            <a:ext cx="2286000" cy="868680"/>
+          </a:xfrm>
+          <a:prstGeom prst="rect">
+            <a:avLst/>
+          </a:prstGeom>
+          <a:noFill/>
+          <a:ln/>
+        </p:spPr>
+        <p:txBody>
+          <a:bodyPr wrap="square" rtlCol="0" anchor="ctr"/>
+          <a:lstStyle/>
+          <a:p>
+            <a:pPr algn="ctr" indent="0" marL="0">
               <a:lnSpc>
-                <a:spcPts val="1800"/>
+                <a:spcPts val="1500"/>
               </a:lnSpc>
               <a:buNone/>
             </a:pPr>
             <a:r>
-              <a:rPr lang="en-US" sz="1300" dirty="0">
+              <a:rPr lang="en-US" sz="1200" dirty="0">
                 <a:solidFill>
                   <a:srgbClr val="5A6661"/>
                 </a:solidFill>
@@ -7630,144 +7752,177 @@
                 <a:ea typeface="Arial" pitchFamily="34" charset="-122"/>
                 <a:cs typeface="Arial" pitchFamily="34" charset="-120"/>
               </a:rPr>
-              <a:t>Reminders, reschedule/cancel links, calendar invites, and the sales@ copy.</a:t>
-            </a:r>
-            <a:endParaRPr lang="en-US" sz="1300" dirty="0"/>
-          </a:p>
-        </p:txBody>
-      </p:sp>
-    </p:spTree>
-  </p:cSld>
-  <p:clrMapOvr>
-    <a:masterClrMapping/>
-  </p:clrMapOvr>
-</p:sld>
-</file>
-
-<file path=ppt/slides/slide8.xml><?xml version="1.0" encoding="utf-8"?>
-<p:sld xmlns:a="http://schemas.openxmlformats.org/drawingml/2006/main" xmlns:r="http://schemas.openxmlformats.org/officeDocument/2006/relationships" xmlns:p="http://schemas.openxmlformats.org/presentationml/2006/main">
-  <p:cSld name="Slide 8">
-    <p:bg>
-      <p:bgPr>
-        <a:solidFill>
-          <a:srgbClr val="16201C"/>
-        </a:solidFill>
-      </p:bgPr>
-    </p:bg>
-    <p:spTree>
-      <p:nvGrpSpPr>
-        <p:cNvPr id="1" name=""/>
-        <p:cNvGrpSpPr/>
-        <p:nvPr/>
-      </p:nvGrpSpPr>
-      <p:grpSpPr>
-        <a:xfrm>
-          <a:off x="0" y="0"/>
-          <a:ext cx="0" cy="0"/>
-          <a:chOff x="0" y="0"/>
-          <a:chExt cx="0" cy="0"/>
-        </a:xfrm>
-      </p:grpSpPr>
-      <p:sp>
-        <p:nvSpPr>
-          <p:cNvPr id="2" name="Text 0"/>
-          <p:cNvSpPr/>
-          <p:nvPr/>
-        </p:nvSpPr>
-        <p:spPr>
-          <a:xfrm>
-            <a:off x="822960" y="640080"/>
-            <a:ext cx="8229600" cy="292608"/>
-          </a:xfrm>
-          <a:prstGeom prst="rect">
-            <a:avLst/>
-          </a:prstGeom>
-          <a:noFill/>
-          <a:ln/>
-        </p:spPr>
-        <p:txBody>
-          <a:bodyPr wrap="square" rtlCol="0" anchor="ctr"/>
-          <a:lstStyle/>
-          <a:p>
-            <a:pPr algn="l" indent="0" marL="0">
-              <a:buNone/>
-            </a:pPr>
-            <a:r>
-              <a:rPr lang="en-US" sz="1250" b="1" spc="300" kern="0" dirty="0">
-                <a:solidFill>
-                  <a:srgbClr val="4FA98A"/>
+              <a:t>Publish + add the 'Book a consultation' button.</a:t>
+            </a:r>
+            <a:endParaRPr lang="en-US" sz="1200" dirty="0"/>
+          </a:p>
+        </p:txBody>
+      </p:sp>
+      <p:sp>
+        <p:nvSpPr>
+          <p:cNvPr id="17" name="Shape 15"/>
+          <p:cNvSpPr/>
+          <p:nvPr/>
+        </p:nvSpPr>
+        <p:spPr>
+          <a:xfrm>
+            <a:off x="8229600" y="3520440"/>
+            <a:ext cx="548640" cy="548640"/>
+          </a:xfrm>
+          <a:prstGeom prst="ellipse">
+            <a:avLst/>
+          </a:prstGeom>
+          <a:solidFill>
+            <a:srgbClr val="16513C"/>
+          </a:solidFill>
+          <a:ln w="38100">
+            <a:solidFill>
+              <a:srgbClr val="FFFFFF"/>
+            </a:solidFill>
+            <a:prstDash val="solid"/>
+          </a:ln>
+        </p:spPr>
+      </p:sp>
+      <p:sp>
+        <p:nvSpPr>
+          <p:cNvPr id="18" name="Text 16"/>
+          <p:cNvSpPr/>
+          <p:nvPr/>
+        </p:nvSpPr>
+        <p:spPr>
+          <a:xfrm>
+            <a:off x="8229600" y="3520440"/>
+            <a:ext cx="548640" cy="548640"/>
+          </a:xfrm>
+          <a:prstGeom prst="rect">
+            <a:avLst/>
+          </a:prstGeom>
+          <a:noFill/>
+          <a:ln/>
+        </p:spPr>
+        <p:txBody>
+          <a:bodyPr wrap="square" rtlCol="0" anchor="ctr"/>
+          <a:lstStyle/>
+          <a:p>
+            <a:pPr algn="ctr" indent="0" marL="0">
+              <a:buNone/>
+            </a:pPr>
+            <a:r>
+              <a:rPr lang="en-US" sz="1200" b="1" dirty="0">
+                <a:solidFill>
+                  <a:srgbClr val="FFFFFF"/>
                 </a:solidFill>
                 <a:latin typeface="Courier New" pitchFamily="34" charset="0"/>
                 <a:ea typeface="Courier New" pitchFamily="34" charset="-122"/>
                 <a:cs typeface="Courier New" pitchFamily="34" charset="-120"/>
               </a:rPr>
-              <a:t>WHAT YOU GET</a:t>
-            </a:r>
-            <a:endParaRPr lang="en-US" sz="1250" dirty="0"/>
-          </a:p>
-        </p:txBody>
-      </p:sp>
-      <p:sp>
-        <p:nvSpPr>
-          <p:cNvPr id="3" name="Text 1"/>
-          <p:cNvSpPr/>
-          <p:nvPr/>
-        </p:nvSpPr>
-        <p:spPr>
-          <a:xfrm>
-            <a:off x="822960" y="960120"/>
-            <a:ext cx="10607040" cy="914400"/>
-          </a:xfrm>
-          <a:prstGeom prst="rect">
-            <a:avLst/>
-          </a:prstGeom>
-          <a:noFill/>
-          <a:ln/>
-        </p:spPr>
-        <p:txBody>
-          <a:bodyPr wrap="square" rtlCol="0" anchor="ctr"/>
-          <a:lstStyle/>
-          <a:p>
-            <a:pPr indent="0" marL="0">
-              <a:buNone/>
-            </a:pPr>
-            <a:r>
-              <a:rPr lang="en-US" sz="3400" b="1" dirty="0">
-                <a:solidFill>
-                  <a:srgbClr val="FFFFFF"/>
-                </a:solidFill>
-                <a:latin typeface="Arial" pitchFamily="34" charset="0"/>
-                <a:ea typeface="Arial" pitchFamily="34" charset="-122"/>
-                <a:cs typeface="Arial" pitchFamily="34" charset="-120"/>
-              </a:rPr>
-              <a:t>Value to outdoor.ie</a:t>
-            </a:r>
-            <a:endParaRPr lang="en-US" sz="3400" dirty="0"/>
-          </a:p>
-        </p:txBody>
-      </p:sp>
-      <p:sp>
-        <p:nvSpPr>
-          <p:cNvPr id="4" name="Shape 2"/>
-          <p:cNvSpPr/>
-          <p:nvPr/>
-        </p:nvSpPr>
-        <p:spPr>
-          <a:xfrm>
-            <a:off x="822960" y="2468880"/>
-            <a:ext cx="5120640" cy="1737360"/>
-          </a:xfrm>
-          <a:prstGeom prst="roundRect">
-            <a:avLst>
-              <a:gd name="adj" fmla="val 4737"/>
-            </a:avLst>
+              <a:t>P4</a:t>
+            </a:r>
+            <a:endParaRPr lang="en-US" sz="1200" dirty="0"/>
+          </a:p>
+        </p:txBody>
+      </p:sp>
+      <p:sp>
+        <p:nvSpPr>
+          <p:cNvPr id="19" name="Text 17"/>
+          <p:cNvSpPr/>
+          <p:nvPr/>
+        </p:nvSpPr>
+        <p:spPr>
+          <a:xfrm>
+            <a:off x="7498080" y="4251960"/>
+            <a:ext cx="2011680" cy="365760"/>
+          </a:xfrm>
+          <a:prstGeom prst="rect">
+            <a:avLst/>
+          </a:prstGeom>
+          <a:noFill/>
+          <a:ln/>
+        </p:spPr>
+        <p:txBody>
+          <a:bodyPr wrap="square" rtlCol="0" anchor="ctr"/>
+          <a:lstStyle/>
+          <a:p>
+            <a:pPr algn="ctr" indent="0" marL="0">
+              <a:buNone/>
+            </a:pPr>
+            <a:r>
+              <a:rPr lang="en-US" sz="1500" b="1" dirty="0">
+                <a:solidFill>
+                  <a:srgbClr val="16201C"/>
+                </a:solidFill>
+                <a:latin typeface="Arial" pitchFamily="34" charset="0"/>
+                <a:ea typeface="Arial" pitchFamily="34" charset="-122"/>
+                <a:cs typeface="Arial" pitchFamily="34" charset="-120"/>
+              </a:rPr>
+              <a:t>Expand</a:t>
+            </a:r>
+            <a:endParaRPr lang="en-US" sz="1500" dirty="0"/>
+          </a:p>
+        </p:txBody>
+      </p:sp>
+      <p:sp>
+        <p:nvSpPr>
+          <p:cNvPr id="20" name="Text 18"/>
+          <p:cNvSpPr/>
+          <p:nvPr/>
+        </p:nvSpPr>
+        <p:spPr>
+          <a:xfrm>
+            <a:off x="7360920" y="4617720"/>
+            <a:ext cx="2286000" cy="868680"/>
+          </a:xfrm>
+          <a:prstGeom prst="rect">
+            <a:avLst/>
+          </a:prstGeom>
+          <a:noFill/>
+          <a:ln/>
+        </p:spPr>
+        <p:txBody>
+          <a:bodyPr wrap="square" rtlCol="0" anchor="ctr"/>
+          <a:lstStyle/>
+          <a:p>
+            <a:pPr algn="ctr" indent="0" marL="0">
+              <a:lnSpc>
+                <a:spcPts val="1500"/>
+              </a:lnSpc>
+              <a:buNone/>
+            </a:pPr>
+            <a:r>
+              <a:rPr lang="en-US" sz="1200" dirty="0">
+                <a:solidFill>
+                  <a:srgbClr val="5A6661"/>
+                </a:solidFill>
+                <a:latin typeface="Arial" pitchFamily="34" charset="0"/>
+                <a:ea typeface="Arial" pitchFamily="34" charset="-122"/>
+                <a:cs typeface="Arial" pitchFamily="34" charset="-120"/>
+              </a:rPr>
+              <a:t>Add booking to other services you offer.</a:t>
+            </a:r>
+            <a:endParaRPr lang="en-US" sz="1200" dirty="0"/>
+          </a:p>
+        </p:txBody>
+      </p:sp>
+      <p:sp>
+        <p:nvSpPr>
+          <p:cNvPr id="21" name="Shape 19"/>
+          <p:cNvSpPr/>
+          <p:nvPr/>
+        </p:nvSpPr>
+        <p:spPr>
+          <a:xfrm>
+            <a:off x="10652760" y="3520440"/>
+            <a:ext cx="548640" cy="548640"/>
+          </a:xfrm>
+          <a:prstGeom prst="ellipse">
+            <a:avLst/>
           </a:prstGeom>
           <a:solidFill>
-            <a:srgbClr val="22302A"/>
+            <a:srgbClr val="16513C"/>
           </a:solidFill>
-          <a:ln w="12700">
+          <a:ln w="38100">
             <a:solidFill>
-              <a:srgbClr val="36473E"/>
+              <a:srgbClr val="FFFFFF"/>
             </a:solidFill>
             <a:prstDash val="solid"/>
           </a:ln>
@@ -7775,34 +7930,14 @@
       </p:sp>
       <p:sp>
         <p:nvSpPr>
-          <p:cNvPr id="5" name="Shape 3"/>
-          <p:cNvSpPr/>
-          <p:nvPr/>
-        </p:nvSpPr>
-        <p:spPr>
-          <a:xfrm>
-            <a:off x="1143000" y="2788920"/>
-            <a:ext cx="457200" cy="457200"/>
-          </a:xfrm>
-          <a:prstGeom prst="ellipse">
-            <a:avLst/>
-          </a:prstGeom>
-          <a:solidFill>
-            <a:srgbClr val="16513C"/>
-          </a:solidFill>
-          <a:ln/>
-        </p:spPr>
-      </p:sp>
-      <p:sp>
-        <p:nvSpPr>
-          <p:cNvPr id="6" name="Text 4"/>
-          <p:cNvSpPr/>
-          <p:nvPr/>
-        </p:nvSpPr>
-        <p:spPr>
-          <a:xfrm>
-            <a:off x="1143000" y="2788920"/>
-            <a:ext cx="457200" cy="457200"/>
+          <p:cNvPr id="22" name="Text 20"/>
+          <p:cNvSpPr/>
+          <p:nvPr/>
+        </p:nvSpPr>
+        <p:spPr>
+          <a:xfrm>
+            <a:off x="10652760" y="3520440"/>
+            <a:ext cx="548640" cy="548640"/>
           </a:xfrm>
           <a:prstGeom prst="rect">
             <a:avLst/>
@@ -7818,7 +7953,7 @@
               <a:buNone/>
             </a:pPr>
             <a:r>
-              <a:rPr lang="en-US" sz="1600" b="1" dirty="0">
+              <a:rPr lang="en-US" sz="1200" b="1" dirty="0">
                 <a:solidFill>
                   <a:srgbClr val="FFFFFF"/>
                 </a:solidFill>
@@ -7826,591 +7961,90 @@
                 <a:ea typeface="Courier New" pitchFamily="34" charset="-122"/>
                 <a:cs typeface="Courier New" pitchFamily="34" charset="-120"/>
               </a:rPr>
-              <a:t>✓</a:t>
-            </a:r>
-            <a:endParaRPr lang="en-US" sz="1600" dirty="0"/>
-          </a:p>
-        </p:txBody>
-      </p:sp>
-      <p:sp>
-        <p:nvSpPr>
-          <p:cNvPr id="7" name="Text 5"/>
-          <p:cNvSpPr/>
-          <p:nvPr/>
-        </p:nvSpPr>
-        <p:spPr>
-          <a:xfrm>
-            <a:off x="1737360" y="2743200"/>
-            <a:ext cx="3931920" cy="457200"/>
-          </a:xfrm>
-          <a:prstGeom prst="rect">
-            <a:avLst/>
-          </a:prstGeom>
-          <a:noFill/>
-          <a:ln/>
-        </p:spPr>
-        <p:txBody>
-          <a:bodyPr wrap="square" rtlCol="0" anchor="ctr"/>
-          <a:lstStyle/>
-          <a:p>
-            <a:pPr indent="0" marL="0">
-              <a:buNone/>
-            </a:pPr>
-            <a:r>
-              <a:rPr lang="en-US" sz="1700" b="1" dirty="0">
-                <a:solidFill>
-                  <a:srgbClr val="FFFFFF"/>
-                </a:solidFill>
-                <a:latin typeface="Arial" pitchFamily="34" charset="0"/>
-                <a:ea typeface="Arial" pitchFamily="34" charset="-122"/>
-                <a:cs typeface="Arial" pitchFamily="34" charset="-120"/>
-              </a:rPr>
-              <a:t>24/7 capture</a:t>
-            </a:r>
-            <a:endParaRPr lang="en-US" sz="1700" dirty="0"/>
-          </a:p>
-        </p:txBody>
-      </p:sp>
-      <p:sp>
-        <p:nvSpPr>
-          <p:cNvPr id="8" name="Text 6"/>
-          <p:cNvSpPr/>
-          <p:nvPr/>
-        </p:nvSpPr>
-        <p:spPr>
-          <a:xfrm>
-            <a:off x="1737360" y="3246120"/>
-            <a:ext cx="3931920" cy="777240"/>
-          </a:xfrm>
-          <a:prstGeom prst="rect">
-            <a:avLst/>
-          </a:prstGeom>
-          <a:noFill/>
-          <a:ln/>
-        </p:spPr>
-        <p:txBody>
-          <a:bodyPr wrap="square" rtlCol="0" anchor="ctr"/>
-          <a:lstStyle/>
-          <a:p>
-            <a:pPr indent="0" marL="0">
+              <a:t>P5</a:t>
+            </a:r>
+            <a:endParaRPr lang="en-US" sz="1200" dirty="0"/>
+          </a:p>
+        </p:txBody>
+      </p:sp>
+      <p:sp>
+        <p:nvSpPr>
+          <p:cNvPr id="23" name="Text 21"/>
+          <p:cNvSpPr/>
+          <p:nvPr/>
+        </p:nvSpPr>
+        <p:spPr>
+          <a:xfrm>
+            <a:off x="9921240" y="2377440"/>
+            <a:ext cx="2011680" cy="365760"/>
+          </a:xfrm>
+          <a:prstGeom prst="rect">
+            <a:avLst/>
+          </a:prstGeom>
+          <a:noFill/>
+          <a:ln/>
+        </p:spPr>
+        <p:txBody>
+          <a:bodyPr wrap="square" rtlCol="0" anchor="ctr"/>
+          <a:lstStyle/>
+          <a:p>
+            <a:pPr algn="ctr" indent="0" marL="0">
+              <a:buNone/>
+            </a:pPr>
+            <a:r>
+              <a:rPr lang="en-US" sz="1500" b="1" dirty="0">
+                <a:solidFill>
+                  <a:srgbClr val="16201C"/>
+                </a:solidFill>
+                <a:latin typeface="Arial" pitchFamily="34" charset="0"/>
+                <a:ea typeface="Arial" pitchFamily="34" charset="-122"/>
+                <a:cs typeface="Arial" pitchFamily="34" charset="-120"/>
+              </a:rPr>
+              <a:t>Insights</a:t>
+            </a:r>
+            <a:endParaRPr lang="en-US" sz="1500" dirty="0"/>
+          </a:p>
+        </p:txBody>
+      </p:sp>
+      <p:sp>
+        <p:nvSpPr>
+          <p:cNvPr id="24" name="Text 22"/>
+          <p:cNvSpPr/>
+          <p:nvPr/>
+        </p:nvSpPr>
+        <p:spPr>
+          <a:xfrm>
+            <a:off x="9784080" y="2743200"/>
+            <a:ext cx="2286000" cy="868680"/>
+          </a:xfrm>
+          <a:prstGeom prst="rect">
+            <a:avLst/>
+          </a:prstGeom>
+          <a:noFill/>
+          <a:ln/>
+        </p:spPr>
+        <p:txBody>
+          <a:bodyPr wrap="square" rtlCol="0" anchor="ctr"/>
+          <a:lstStyle/>
+          <a:p>
+            <a:pPr algn="ctr" indent="0" marL="0">
               <a:lnSpc>
-                <a:spcPts val="1700"/>
+                <a:spcPts val="1500"/>
               </a:lnSpc>
               <a:buNone/>
             </a:pPr>
             <a:r>
-              <a:rPr lang="en-US" sz="1300" dirty="0">
-                <a:solidFill>
-                  <a:srgbClr val="C9D4CF"/>
-                </a:solidFill>
-                <a:latin typeface="Arial" pitchFamily="34" charset="0"/>
-                <a:ea typeface="Arial" pitchFamily="34" charset="-122"/>
-                <a:cs typeface="Arial" pitchFamily="34" charset="-120"/>
-              </a:rPr>
-              <a:t>Warm leads book themselves, even outside office hours.</a:t>
-            </a:r>
-            <a:endParaRPr lang="en-US" sz="1300" dirty="0"/>
-          </a:p>
-        </p:txBody>
-      </p:sp>
-      <p:sp>
-        <p:nvSpPr>
-          <p:cNvPr id="9" name="Shape 7"/>
-          <p:cNvSpPr/>
-          <p:nvPr/>
-        </p:nvSpPr>
-        <p:spPr>
-          <a:xfrm>
-            <a:off x="6355080" y="2468880"/>
-            <a:ext cx="5120640" cy="1737360"/>
-          </a:xfrm>
-          <a:prstGeom prst="roundRect">
-            <a:avLst>
-              <a:gd name="adj" fmla="val 4737"/>
-            </a:avLst>
-          </a:prstGeom>
-          <a:solidFill>
-            <a:srgbClr val="22302A"/>
-          </a:solidFill>
-          <a:ln w="12700">
-            <a:solidFill>
-              <a:srgbClr val="36473E"/>
-            </a:solidFill>
-            <a:prstDash val="solid"/>
-          </a:ln>
-        </p:spPr>
-      </p:sp>
-      <p:sp>
-        <p:nvSpPr>
-          <p:cNvPr id="10" name="Shape 8"/>
-          <p:cNvSpPr/>
-          <p:nvPr/>
-        </p:nvSpPr>
-        <p:spPr>
-          <a:xfrm>
-            <a:off x="6675120" y="2788920"/>
-            <a:ext cx="457200" cy="457200"/>
-          </a:xfrm>
-          <a:prstGeom prst="ellipse">
-            <a:avLst/>
-          </a:prstGeom>
-          <a:solidFill>
-            <a:srgbClr val="16513C"/>
-          </a:solidFill>
-          <a:ln/>
-        </p:spPr>
-      </p:sp>
-      <p:sp>
-        <p:nvSpPr>
-          <p:cNvPr id="11" name="Text 9"/>
-          <p:cNvSpPr/>
-          <p:nvPr/>
-        </p:nvSpPr>
-        <p:spPr>
-          <a:xfrm>
-            <a:off x="6675120" y="2788920"/>
-            <a:ext cx="457200" cy="457200"/>
-          </a:xfrm>
-          <a:prstGeom prst="rect">
-            <a:avLst/>
-          </a:prstGeom>
-          <a:noFill/>
-          <a:ln/>
-        </p:spPr>
-        <p:txBody>
-          <a:bodyPr wrap="square" rtlCol="0" anchor="ctr"/>
-          <a:lstStyle/>
-          <a:p>
-            <a:pPr algn="ctr" indent="0" marL="0">
-              <a:buNone/>
-            </a:pPr>
-            <a:r>
-              <a:rPr lang="en-US" sz="1600" b="1" dirty="0">
-                <a:solidFill>
-                  <a:srgbClr val="FFFFFF"/>
-                </a:solidFill>
-                <a:latin typeface="Courier New" pitchFamily="34" charset="0"/>
-                <a:ea typeface="Courier New" pitchFamily="34" charset="-122"/>
-                <a:cs typeface="Courier New" pitchFamily="34" charset="-120"/>
-              </a:rPr>
-              <a:t>✓</a:t>
-            </a:r>
-            <a:endParaRPr lang="en-US" sz="1600" dirty="0"/>
-          </a:p>
-        </p:txBody>
-      </p:sp>
-      <p:sp>
-        <p:nvSpPr>
-          <p:cNvPr id="12" name="Text 10"/>
-          <p:cNvSpPr/>
-          <p:nvPr/>
-        </p:nvSpPr>
-        <p:spPr>
-          <a:xfrm>
-            <a:off x="7269480" y="2743200"/>
-            <a:ext cx="3931920" cy="457200"/>
-          </a:xfrm>
-          <a:prstGeom prst="rect">
-            <a:avLst/>
-          </a:prstGeom>
-          <a:noFill/>
-          <a:ln/>
-        </p:spPr>
-        <p:txBody>
-          <a:bodyPr wrap="square" rtlCol="0" anchor="ctr"/>
-          <a:lstStyle/>
-          <a:p>
-            <a:pPr indent="0" marL="0">
-              <a:buNone/>
-            </a:pPr>
-            <a:r>
-              <a:rPr lang="en-US" sz="1700" b="1" dirty="0">
-                <a:solidFill>
-                  <a:srgbClr val="FFFFFF"/>
-                </a:solidFill>
-                <a:latin typeface="Arial" pitchFamily="34" charset="0"/>
-                <a:ea typeface="Arial" pitchFamily="34" charset="-122"/>
-                <a:cs typeface="Arial" pitchFamily="34" charset="-120"/>
-              </a:rPr>
-              <a:t>Zero scheduling time</a:t>
-            </a:r>
-            <a:endParaRPr lang="en-US" sz="1700" dirty="0"/>
-          </a:p>
-        </p:txBody>
-      </p:sp>
-      <p:sp>
-        <p:nvSpPr>
-          <p:cNvPr id="13" name="Text 11"/>
-          <p:cNvSpPr/>
-          <p:nvPr/>
-        </p:nvSpPr>
-        <p:spPr>
-          <a:xfrm>
-            <a:off x="7269480" y="3246120"/>
-            <a:ext cx="3931920" cy="777240"/>
-          </a:xfrm>
-          <a:prstGeom prst="rect">
-            <a:avLst/>
-          </a:prstGeom>
-          <a:noFill/>
-          <a:ln/>
-        </p:spPr>
-        <p:txBody>
-          <a:bodyPr wrap="square" rtlCol="0" anchor="ctr"/>
-          <a:lstStyle/>
-          <a:p>
-            <a:pPr indent="0" marL="0">
-              <a:lnSpc>
-                <a:spcPts val="1700"/>
-              </a:lnSpc>
-              <a:buNone/>
-            </a:pPr>
-            <a:r>
-              <a:rPr lang="en-US" sz="1300" dirty="0">
-                <a:solidFill>
-                  <a:srgbClr val="C9D4CF"/>
-                </a:solidFill>
-                <a:latin typeface="Arial" pitchFamily="34" charset="0"/>
-                <a:ea typeface="Arial" pitchFamily="34" charset="-122"/>
-                <a:cs typeface="Arial" pitchFamily="34" charset="-120"/>
-              </a:rPr>
-              <a:t>No one manually arranges or chases consultations.</a:t>
-            </a:r>
-            <a:endParaRPr lang="en-US" sz="1300" dirty="0"/>
-          </a:p>
-        </p:txBody>
-      </p:sp>
-      <p:sp>
-        <p:nvSpPr>
-          <p:cNvPr id="14" name="Shape 12"/>
-          <p:cNvSpPr/>
-          <p:nvPr/>
-        </p:nvSpPr>
-        <p:spPr>
-          <a:xfrm>
-            <a:off x="822960" y="4480560"/>
-            <a:ext cx="5120640" cy="1737360"/>
-          </a:xfrm>
-          <a:prstGeom prst="roundRect">
-            <a:avLst>
-              <a:gd name="adj" fmla="val 4737"/>
-            </a:avLst>
-          </a:prstGeom>
-          <a:solidFill>
-            <a:srgbClr val="22302A"/>
-          </a:solidFill>
-          <a:ln w="12700">
-            <a:solidFill>
-              <a:srgbClr val="36473E"/>
-            </a:solidFill>
-            <a:prstDash val="solid"/>
-          </a:ln>
-        </p:spPr>
-      </p:sp>
-      <p:sp>
-        <p:nvSpPr>
-          <p:cNvPr id="15" name="Shape 13"/>
-          <p:cNvSpPr/>
-          <p:nvPr/>
-        </p:nvSpPr>
-        <p:spPr>
-          <a:xfrm>
-            <a:off x="1143000" y="4800600"/>
-            <a:ext cx="457200" cy="457200"/>
-          </a:xfrm>
-          <a:prstGeom prst="ellipse">
-            <a:avLst/>
-          </a:prstGeom>
-          <a:solidFill>
-            <a:srgbClr val="16513C"/>
-          </a:solidFill>
-          <a:ln/>
-        </p:spPr>
-      </p:sp>
-      <p:sp>
-        <p:nvSpPr>
-          <p:cNvPr id="16" name="Text 14"/>
-          <p:cNvSpPr/>
-          <p:nvPr/>
-        </p:nvSpPr>
-        <p:spPr>
-          <a:xfrm>
-            <a:off x="1143000" y="4800600"/>
-            <a:ext cx="457200" cy="457200"/>
-          </a:xfrm>
-          <a:prstGeom prst="rect">
-            <a:avLst/>
-          </a:prstGeom>
-          <a:noFill/>
-          <a:ln/>
-        </p:spPr>
-        <p:txBody>
-          <a:bodyPr wrap="square" rtlCol="0" anchor="ctr"/>
-          <a:lstStyle/>
-          <a:p>
-            <a:pPr algn="ctr" indent="0" marL="0">
-              <a:buNone/>
-            </a:pPr>
-            <a:r>
-              <a:rPr lang="en-US" sz="1600" b="1" dirty="0">
-                <a:solidFill>
-                  <a:srgbClr val="FFFFFF"/>
-                </a:solidFill>
-                <a:latin typeface="Courier New" pitchFamily="34" charset="0"/>
-                <a:ea typeface="Courier New" pitchFamily="34" charset="-122"/>
-                <a:cs typeface="Courier New" pitchFamily="34" charset="-120"/>
-              </a:rPr>
-              <a:t>✓</a:t>
-            </a:r>
-            <a:endParaRPr lang="en-US" sz="1600" dirty="0"/>
-          </a:p>
-        </p:txBody>
-      </p:sp>
-      <p:sp>
-        <p:nvSpPr>
-          <p:cNvPr id="17" name="Text 15"/>
-          <p:cNvSpPr/>
-          <p:nvPr/>
-        </p:nvSpPr>
-        <p:spPr>
-          <a:xfrm>
-            <a:off x="1737360" y="4754880"/>
-            <a:ext cx="3931920" cy="457200"/>
-          </a:xfrm>
-          <a:prstGeom prst="rect">
-            <a:avLst/>
-          </a:prstGeom>
-          <a:noFill/>
-          <a:ln/>
-        </p:spPr>
-        <p:txBody>
-          <a:bodyPr wrap="square" rtlCol="0" anchor="ctr"/>
-          <a:lstStyle/>
-          <a:p>
-            <a:pPr indent="0" marL="0">
-              <a:buNone/>
-            </a:pPr>
-            <a:r>
-              <a:rPr lang="en-US" sz="1700" b="1" dirty="0">
-                <a:solidFill>
-                  <a:srgbClr val="FFFFFF"/>
-                </a:solidFill>
-                <a:latin typeface="Arial" pitchFamily="34" charset="0"/>
-                <a:ea typeface="Arial" pitchFamily="34" charset="-122"/>
-                <a:cs typeface="Arial" pitchFamily="34" charset="-120"/>
-              </a:rPr>
-              <a:t>Runs on what you have</a:t>
-            </a:r>
-            <a:endParaRPr lang="en-US" sz="1700" dirty="0"/>
-          </a:p>
-        </p:txBody>
-      </p:sp>
-      <p:sp>
-        <p:nvSpPr>
-          <p:cNvPr id="18" name="Text 16"/>
-          <p:cNvSpPr/>
-          <p:nvPr/>
-        </p:nvSpPr>
-        <p:spPr>
-          <a:xfrm>
-            <a:off x="1737360" y="5257800"/>
-            <a:ext cx="3931920" cy="777240"/>
-          </a:xfrm>
-          <a:prstGeom prst="rect">
-            <a:avLst/>
-          </a:prstGeom>
-          <a:noFill/>
-          <a:ln/>
-        </p:spPr>
-        <p:txBody>
-          <a:bodyPr wrap="square" rtlCol="0" anchor="ctr"/>
-          <a:lstStyle/>
-          <a:p>
-            <a:pPr indent="0" marL="0">
-              <a:lnSpc>
-                <a:spcPts val="1700"/>
-              </a:lnSpc>
-              <a:buNone/>
-            </a:pPr>
-            <a:r>
-              <a:rPr lang="en-US" sz="1300" dirty="0">
-                <a:solidFill>
-                  <a:srgbClr val="C9D4CF"/>
-                </a:solidFill>
-                <a:latin typeface="Arial" pitchFamily="34" charset="0"/>
-                <a:ea typeface="Arial" pitchFamily="34" charset="-122"/>
-                <a:cs typeface="Arial" pitchFamily="34" charset="-120"/>
-              </a:rPr>
-              <a:t>Sits on your existing WordPress site. No new platform.</a:t>
-            </a:r>
-            <a:endParaRPr lang="en-US" sz="1300" dirty="0"/>
-          </a:p>
-        </p:txBody>
-      </p:sp>
-      <p:sp>
-        <p:nvSpPr>
-          <p:cNvPr id="19" name="Shape 17"/>
-          <p:cNvSpPr/>
-          <p:nvPr/>
-        </p:nvSpPr>
-        <p:spPr>
-          <a:xfrm>
-            <a:off x="6355080" y="4480560"/>
-            <a:ext cx="5120640" cy="1737360"/>
-          </a:xfrm>
-          <a:prstGeom prst="roundRect">
-            <a:avLst>
-              <a:gd name="adj" fmla="val 4737"/>
-            </a:avLst>
-          </a:prstGeom>
-          <a:solidFill>
-            <a:srgbClr val="22302A"/>
-          </a:solidFill>
-          <a:ln w="12700">
-            <a:solidFill>
-              <a:srgbClr val="36473E"/>
-            </a:solidFill>
-            <a:prstDash val="solid"/>
-          </a:ln>
-        </p:spPr>
-      </p:sp>
-      <p:sp>
-        <p:nvSpPr>
-          <p:cNvPr id="20" name="Shape 18"/>
-          <p:cNvSpPr/>
-          <p:nvPr/>
-        </p:nvSpPr>
-        <p:spPr>
-          <a:xfrm>
-            <a:off x="6675120" y="4800600"/>
-            <a:ext cx="457200" cy="457200"/>
-          </a:xfrm>
-          <a:prstGeom prst="ellipse">
-            <a:avLst/>
-          </a:prstGeom>
-          <a:solidFill>
-            <a:srgbClr val="16513C"/>
-          </a:solidFill>
-          <a:ln/>
-        </p:spPr>
-      </p:sp>
-      <p:sp>
-        <p:nvSpPr>
-          <p:cNvPr id="21" name="Text 19"/>
-          <p:cNvSpPr/>
-          <p:nvPr/>
-        </p:nvSpPr>
-        <p:spPr>
-          <a:xfrm>
-            <a:off x="6675120" y="4800600"/>
-            <a:ext cx="457200" cy="457200"/>
-          </a:xfrm>
-          <a:prstGeom prst="rect">
-            <a:avLst/>
-          </a:prstGeom>
-          <a:noFill/>
-          <a:ln/>
-        </p:spPr>
-        <p:txBody>
-          <a:bodyPr wrap="square" rtlCol="0" anchor="ctr"/>
-          <a:lstStyle/>
-          <a:p>
-            <a:pPr algn="ctr" indent="0" marL="0">
-              <a:buNone/>
-            </a:pPr>
-            <a:r>
-              <a:rPr lang="en-US" sz="1600" b="1" dirty="0">
-                <a:solidFill>
-                  <a:srgbClr val="FFFFFF"/>
-                </a:solidFill>
-                <a:latin typeface="Courier New" pitchFamily="34" charset="0"/>
-                <a:ea typeface="Courier New" pitchFamily="34" charset="-122"/>
-                <a:cs typeface="Courier New" pitchFamily="34" charset="-120"/>
-              </a:rPr>
-              <a:t>✓</a:t>
-            </a:r>
-            <a:endParaRPr lang="en-US" sz="1600" dirty="0"/>
-          </a:p>
-        </p:txBody>
-      </p:sp>
-      <p:sp>
-        <p:nvSpPr>
-          <p:cNvPr id="22" name="Text 20"/>
-          <p:cNvSpPr/>
-          <p:nvPr/>
-        </p:nvSpPr>
-        <p:spPr>
-          <a:xfrm>
-            <a:off x="7269480" y="4754880"/>
-            <a:ext cx="3931920" cy="457200"/>
-          </a:xfrm>
-          <a:prstGeom prst="rect">
-            <a:avLst/>
-          </a:prstGeom>
-          <a:noFill/>
-          <a:ln/>
-        </p:spPr>
-        <p:txBody>
-          <a:bodyPr wrap="square" rtlCol="0" anchor="ctr"/>
-          <a:lstStyle/>
-          <a:p>
-            <a:pPr indent="0" marL="0">
-              <a:buNone/>
-            </a:pPr>
-            <a:r>
-              <a:rPr lang="en-US" sz="1700" b="1" dirty="0">
-                <a:solidFill>
-                  <a:srgbClr val="FFFFFF"/>
-                </a:solidFill>
-                <a:latin typeface="Arial" pitchFamily="34" charset="0"/>
-                <a:ea typeface="Arial" pitchFamily="34" charset="-122"/>
-                <a:cs typeface="Arial" pitchFamily="34" charset="-120"/>
-              </a:rPr>
-              <a:t>Fewer lost enquiries</a:t>
-            </a:r>
-            <a:endParaRPr lang="en-US" sz="1700" dirty="0"/>
-          </a:p>
-        </p:txBody>
-      </p:sp>
-      <p:sp>
-        <p:nvSpPr>
-          <p:cNvPr id="23" name="Text 21"/>
-          <p:cNvSpPr/>
-          <p:nvPr/>
-        </p:nvSpPr>
-        <p:spPr>
-          <a:xfrm>
-            <a:off x="7269480" y="5257800"/>
-            <a:ext cx="3931920" cy="777240"/>
-          </a:xfrm>
-          <a:prstGeom prst="rect">
-            <a:avLst/>
-          </a:prstGeom>
-          <a:noFill/>
-          <a:ln/>
-        </p:spPr>
-        <p:txBody>
-          <a:bodyPr wrap="square" rtlCol="0" anchor="ctr"/>
-          <a:lstStyle/>
-          <a:p>
-            <a:pPr indent="0" marL="0">
-              <a:lnSpc>
-                <a:spcPts val="1700"/>
-              </a:lnSpc>
-              <a:buNone/>
-            </a:pPr>
-            <a:r>
-              <a:rPr lang="en-US" sz="1300" dirty="0">
-                <a:solidFill>
-                  <a:srgbClr val="C9D4CF"/>
-                </a:solidFill>
-                <a:latin typeface="Arial" pitchFamily="34" charset="0"/>
-                <a:ea typeface="Arial" pitchFamily="34" charset="-122"/>
-                <a:cs typeface="Arial" pitchFamily="34" charset="-120"/>
-              </a:rPr>
-              <a:t>A real next step on the page instead of a dead end.</a:t>
-            </a:r>
-            <a:endParaRPr lang="en-US" sz="1300" dirty="0"/>
+              <a:rPr lang="en-US" sz="1200" dirty="0">
+                <a:solidFill>
+                  <a:srgbClr val="5A6661"/>
+                </a:solidFill>
+                <a:latin typeface="Arial" pitchFamily="34" charset="0"/>
+                <a:ea typeface="Arial" pitchFamily="34" charset="-122"/>
+                <a:cs typeface="Arial" pitchFamily="34" charset="-120"/>
+              </a:rPr>
+              <a:t>Review booking patterns and busy periods.</a:t>
+            </a:r>
+            <a:endParaRPr lang="en-US" sz="1200" dirty="0"/>
           </a:p>
         </p:txBody>
       </p:sp>
@@ -8479,7 +8113,7 @@
                 <a:ea typeface="Courier New" pitchFamily="34" charset="-122"/>
                 <a:cs typeface="Courier New" pitchFamily="34" charset="-120"/>
               </a:rPr>
-              <a:t>ROADMAP</a:t>
+              <a:t>GO TO MARKET</a:t>
             </a:r>
             <a:endParaRPr lang="en-US" sz="1250" dirty="0"/>
           </a:p>
@@ -8521,7 +8155,7 @@
                 <a:ea typeface="Arial" pitchFamily="34" charset="-122"/>
                 <a:cs typeface="Arial" pitchFamily="34" charset="-120"/>
               </a:rPr>
-              <a:t>From preview to live</a:t>
+              <a:t>Catching customers at intent</a:t>
             </a:r>
             <a:endParaRPr lang="en-US" sz="3300" dirty="0"/>
           </a:p>
@@ -8535,14 +8169,18 @@
         </p:nvSpPr>
         <p:spPr>
           <a:xfrm>
-            <a:off x="1234440" y="3794760"/>
-            <a:ext cx="9692640" cy="0"/>
-          </a:xfrm>
-          <a:prstGeom prst="line">
-            <a:avLst/>
-          </a:prstGeom>
-          <a:noFill/>
-          <a:ln w="25400">
+            <a:off x="822960" y="2514600"/>
+            <a:ext cx="5120640" cy="1737360"/>
+          </a:xfrm>
+          <a:prstGeom prst="roundRect">
+            <a:avLst>
+              <a:gd name="adj" fmla="val 4737"/>
+            </a:avLst>
+          </a:prstGeom>
+          <a:solidFill>
+            <a:srgbClr val="F4F6F4"/>
+          </a:solidFill>
+          <a:ln w="12700">
             <a:solidFill>
               <a:srgbClr val="E2E4E0"/>
             </a:solidFill>
@@ -8552,24 +8190,107 @@
       </p:sp>
       <p:sp>
         <p:nvSpPr>
-          <p:cNvPr id="5" name="Shape 3"/>
-          <p:cNvSpPr/>
-          <p:nvPr/>
-        </p:nvSpPr>
-        <p:spPr>
-          <a:xfrm>
-            <a:off x="960120" y="3520440"/>
-            <a:ext cx="548640" cy="548640"/>
-          </a:xfrm>
-          <a:prstGeom prst="ellipse">
-            <a:avLst/>
+          <p:cNvPr id="5" name="Text 3"/>
+          <p:cNvSpPr/>
+          <p:nvPr/>
+        </p:nvSpPr>
+        <p:spPr>
+          <a:xfrm>
+            <a:off x="1188720" y="2788920"/>
+            <a:ext cx="4389120" cy="457200"/>
+          </a:xfrm>
+          <a:prstGeom prst="rect">
+            <a:avLst/>
+          </a:prstGeom>
+          <a:noFill/>
+          <a:ln/>
+        </p:spPr>
+        <p:txBody>
+          <a:bodyPr wrap="square" rtlCol="0" anchor="ctr"/>
+          <a:lstStyle/>
+          <a:p>
+            <a:pPr indent="0" marL="0">
+              <a:buNone/>
+            </a:pPr>
+            <a:r>
+              <a:rPr lang="en-US" sz="1700" b="1" dirty="0">
+                <a:solidFill>
+                  <a:srgbClr val="16513C"/>
+                </a:solidFill>
+                <a:latin typeface="Arial" pitchFamily="34" charset="0"/>
+                <a:ea typeface="Arial" pitchFamily="34" charset="-122"/>
+                <a:cs typeface="Arial" pitchFamily="34" charset="-120"/>
+              </a:rPr>
+              <a:t>Button on pergola pages</a:t>
+            </a:r>
+            <a:endParaRPr lang="en-US" sz="1700" dirty="0"/>
+          </a:p>
+        </p:txBody>
+      </p:sp>
+      <p:sp>
+        <p:nvSpPr>
+          <p:cNvPr id="6" name="Text 4"/>
+          <p:cNvSpPr/>
+          <p:nvPr/>
+        </p:nvSpPr>
+        <p:spPr>
+          <a:xfrm>
+            <a:off x="1188720" y="3291840"/>
+            <a:ext cx="4389120" cy="777240"/>
+          </a:xfrm>
+          <a:prstGeom prst="rect">
+            <a:avLst/>
+          </a:prstGeom>
+          <a:noFill/>
+          <a:ln/>
+        </p:spPr>
+        <p:txBody>
+          <a:bodyPr wrap="square" rtlCol="0" anchor="ctr"/>
+          <a:lstStyle/>
+          <a:p>
+            <a:pPr indent="0" marL="0">
+              <a:lnSpc>
+                <a:spcPts val="1800"/>
+              </a:lnSpc>
+              <a:buNone/>
+            </a:pPr>
+            <a:r>
+              <a:rPr lang="en-US" sz="1300" dirty="0">
+                <a:solidFill>
+                  <a:srgbClr val="5A6661"/>
+                </a:solidFill>
+                <a:latin typeface="Arial" pitchFamily="34" charset="0"/>
+                <a:ea typeface="Arial" pitchFamily="34" charset="-122"/>
+                <a:cs typeface="Arial" pitchFamily="34" charset="-120"/>
+              </a:rPr>
+              <a:t>'Book a free consultation' sits where the decision is made.</a:t>
+            </a:r>
+            <a:endParaRPr lang="en-US" sz="1300" dirty="0"/>
+          </a:p>
+        </p:txBody>
+      </p:sp>
+      <p:sp>
+        <p:nvSpPr>
+          <p:cNvPr id="7" name="Shape 5"/>
+          <p:cNvSpPr/>
+          <p:nvPr/>
+        </p:nvSpPr>
+        <p:spPr>
+          <a:xfrm>
+            <a:off x="6355080" y="2514600"/>
+            <a:ext cx="5120640" cy="1737360"/>
+          </a:xfrm>
+          <a:prstGeom prst="roundRect">
+            <a:avLst>
+              <a:gd name="adj" fmla="val 4737"/>
+            </a:avLst>
           </a:prstGeom>
           <a:solidFill>
-            <a:srgbClr val="16513C"/>
+            <a:srgbClr val="F4F6F4"/>
           </a:solidFill>
-          <a:ln w="38100">
+          <a:ln w="12700">
             <a:solidFill>
-              <a:srgbClr val="FFFFFF"/>
+              <a:srgbClr val="E2E4E0"/>
             </a:solidFill>
             <a:prstDash val="solid"/>
           </a:ln>
@@ -8577,111 +8298,72 @@
       </p:sp>
       <p:sp>
         <p:nvSpPr>
-          <p:cNvPr id="6" name="Text 4"/>
-          <p:cNvSpPr/>
-          <p:nvPr/>
-        </p:nvSpPr>
-        <p:spPr>
-          <a:xfrm>
-            <a:off x="960120" y="3520440"/>
-            <a:ext cx="548640" cy="548640"/>
-          </a:xfrm>
-          <a:prstGeom prst="rect">
-            <a:avLst/>
-          </a:prstGeom>
-          <a:noFill/>
-          <a:ln/>
-        </p:spPr>
-        <p:txBody>
-          <a:bodyPr wrap="square" rtlCol="0" anchor="ctr"/>
-          <a:lstStyle/>
-          <a:p>
-            <a:pPr algn="ctr" indent="0" marL="0">
-              <a:buNone/>
-            </a:pPr>
-            <a:r>
-              <a:rPr lang="en-US" sz="1200" b="1" dirty="0">
-                <a:solidFill>
-                  <a:srgbClr val="FFFFFF"/>
-                </a:solidFill>
-                <a:latin typeface="Courier New" pitchFamily="34" charset="0"/>
-                <a:ea typeface="Courier New" pitchFamily="34" charset="-122"/>
-                <a:cs typeface="Courier New" pitchFamily="34" charset="-120"/>
-              </a:rPr>
-              <a:t>P1</a:t>
-            </a:r>
-            <a:endParaRPr lang="en-US" sz="1200" dirty="0"/>
-          </a:p>
-        </p:txBody>
-      </p:sp>
-      <p:sp>
-        <p:nvSpPr>
-          <p:cNvPr id="7" name="Text 5"/>
-          <p:cNvSpPr/>
-          <p:nvPr/>
-        </p:nvSpPr>
-        <p:spPr>
-          <a:xfrm>
-            <a:off x="228600" y="2377440"/>
-            <a:ext cx="2011680" cy="365760"/>
-          </a:xfrm>
-          <a:prstGeom prst="rect">
-            <a:avLst/>
-          </a:prstGeom>
-          <a:noFill/>
-          <a:ln/>
-        </p:spPr>
-        <p:txBody>
-          <a:bodyPr wrap="square" rtlCol="0" anchor="ctr"/>
-          <a:lstStyle/>
-          <a:p>
-            <a:pPr algn="ctr" indent="0" marL="0">
-              <a:buNone/>
-            </a:pPr>
-            <a:r>
-              <a:rPr lang="en-US" sz="1500" b="1" dirty="0">
-                <a:solidFill>
-                  <a:srgbClr val="16201C"/>
-                </a:solidFill>
-                <a:latin typeface="Arial" pitchFamily="34" charset="0"/>
-                <a:ea typeface="Arial" pitchFamily="34" charset="-122"/>
-                <a:cs typeface="Arial" pitchFamily="34" charset="-120"/>
-              </a:rPr>
-              <a:t>Preview</a:t>
-            </a:r>
-            <a:endParaRPr lang="en-US" sz="1500" dirty="0"/>
-          </a:p>
-        </p:txBody>
-      </p:sp>
-      <p:sp>
-        <p:nvSpPr>
           <p:cNvPr id="8" name="Text 6"/>
           <p:cNvSpPr/>
           <p:nvPr/>
         </p:nvSpPr>
         <p:spPr>
           <a:xfrm>
-            <a:off x="91440" y="2743200"/>
-            <a:ext cx="2286000" cy="868680"/>
-          </a:xfrm>
-          <a:prstGeom prst="rect">
-            <a:avLst/>
-          </a:prstGeom>
-          <a:noFill/>
-          <a:ln/>
-        </p:spPr>
-        <p:txBody>
-          <a:bodyPr wrap="square" rtlCol="0" anchor="ctr"/>
-          <a:lstStyle/>
-          <a:p>
-            <a:pPr algn="ctr" indent="0" marL="0">
+            <a:off x="6720840" y="2788920"/>
+            <a:ext cx="4389120" cy="457200"/>
+          </a:xfrm>
+          <a:prstGeom prst="rect">
+            <a:avLst/>
+          </a:prstGeom>
+          <a:noFill/>
+          <a:ln/>
+        </p:spPr>
+        <p:txBody>
+          <a:bodyPr wrap="square" rtlCol="0" anchor="ctr"/>
+          <a:lstStyle/>
+          <a:p>
+            <a:pPr indent="0" marL="0">
+              <a:buNone/>
+            </a:pPr>
+            <a:r>
+              <a:rPr lang="en-US" sz="1700" b="1" dirty="0">
+                <a:solidFill>
+                  <a:srgbClr val="16513C"/>
+                </a:solidFill>
+                <a:latin typeface="Arial" pitchFamily="34" charset="0"/>
+                <a:ea typeface="Arial" pitchFamily="34" charset="-122"/>
+                <a:cs typeface="Arial" pitchFamily="34" charset="-120"/>
+              </a:rPr>
+              <a:t>Intercept, don't interrupt</a:t>
+            </a:r>
+            <a:endParaRPr lang="en-US" sz="1700" dirty="0"/>
+          </a:p>
+        </p:txBody>
+      </p:sp>
+      <p:sp>
+        <p:nvSpPr>
+          <p:cNvPr id="9" name="Text 7"/>
+          <p:cNvSpPr/>
+          <p:nvPr/>
+        </p:nvSpPr>
+        <p:spPr>
+          <a:xfrm>
+            <a:off x="6720840" y="3291840"/>
+            <a:ext cx="4389120" cy="777240"/>
+          </a:xfrm>
+          <a:prstGeom prst="rect">
+            <a:avLst/>
+          </a:prstGeom>
+          <a:noFill/>
+          <a:ln/>
+        </p:spPr>
+        <p:txBody>
+          <a:bodyPr wrap="square" rtlCol="0" anchor="ctr"/>
+          <a:lstStyle/>
+          <a:p>
+            <a:pPr indent="0" marL="0">
               <a:lnSpc>
-                <a:spcPts val="1500"/>
+                <a:spcPts val="1800"/>
               </a:lnSpc>
               <a:buNone/>
             </a:pPr>
             <a:r>
-              <a:rPr lang="en-US" sz="1200" dirty="0">
+              <a:rPr lang="en-US" sz="1300" dirty="0">
                 <a:solidFill>
                   <a:srgbClr val="5A6661"/>
                 </a:solidFill>
@@ -8689,32 +8371,34 @@
                 <a:ea typeface="Arial" pitchFamily="34" charset="-122"/>
                 <a:cs typeface="Arial" pitchFamily="34" charset="-120"/>
               </a:rPr>
-              <a:t>Test on a draft page, no one sees it yet.</a:t>
-            </a:r>
-            <a:endParaRPr lang="en-US" sz="1200" dirty="0"/>
-          </a:p>
-        </p:txBody>
-      </p:sp>
-      <p:sp>
-        <p:nvSpPr>
-          <p:cNvPr id="9" name="Shape 7"/>
-          <p:cNvSpPr/>
-          <p:nvPr/>
-        </p:nvSpPr>
-        <p:spPr>
-          <a:xfrm>
-            <a:off x="3383280" y="3520440"/>
-            <a:ext cx="548640" cy="548640"/>
-          </a:xfrm>
-          <a:prstGeom prst="ellipse">
-            <a:avLst/>
+              <a:t>Offer a time to people already interested — not a cold ask.</a:t>
+            </a:r>
+            <a:endParaRPr lang="en-US" sz="1300" dirty="0"/>
+          </a:p>
+        </p:txBody>
+      </p:sp>
+      <p:sp>
+        <p:nvSpPr>
+          <p:cNvPr id="10" name="Shape 8"/>
+          <p:cNvSpPr/>
+          <p:nvPr/>
+        </p:nvSpPr>
+        <p:spPr>
+          <a:xfrm>
+            <a:off x="822960" y="4526280"/>
+            <a:ext cx="5120640" cy="1737360"/>
+          </a:xfrm>
+          <a:prstGeom prst="roundRect">
+            <a:avLst>
+              <a:gd name="adj" fmla="val 4737"/>
+            </a:avLst>
           </a:prstGeom>
           <a:solidFill>
-            <a:srgbClr val="16513C"/>
+            <a:srgbClr val="F4F6F4"/>
           </a:solidFill>
-          <a:ln w="38100">
+          <a:ln w="12700">
             <a:solidFill>
-              <a:srgbClr val="FFFFFF"/>
+              <a:srgbClr val="E2E4E0"/>
             </a:solidFill>
             <a:prstDash val="solid"/>
           </a:ln>
@@ -8722,79 +8406,40 @@
       </p:sp>
       <p:sp>
         <p:nvSpPr>
-          <p:cNvPr id="10" name="Text 8"/>
-          <p:cNvSpPr/>
-          <p:nvPr/>
-        </p:nvSpPr>
-        <p:spPr>
-          <a:xfrm>
-            <a:off x="3383280" y="3520440"/>
-            <a:ext cx="548640" cy="548640"/>
-          </a:xfrm>
-          <a:prstGeom prst="rect">
-            <a:avLst/>
-          </a:prstGeom>
-          <a:noFill/>
-          <a:ln/>
-        </p:spPr>
-        <p:txBody>
-          <a:bodyPr wrap="square" rtlCol="0" anchor="ctr"/>
-          <a:lstStyle/>
-          <a:p>
-            <a:pPr algn="ctr" indent="0" marL="0">
-              <a:buNone/>
-            </a:pPr>
-            <a:r>
-              <a:rPr lang="en-US" sz="1200" b="1" dirty="0">
-                <a:solidFill>
-                  <a:srgbClr val="FFFFFF"/>
-                </a:solidFill>
-                <a:latin typeface="Courier New" pitchFamily="34" charset="0"/>
-                <a:ea typeface="Courier New" pitchFamily="34" charset="-122"/>
-                <a:cs typeface="Courier New" pitchFamily="34" charset="-120"/>
-              </a:rPr>
-              <a:t>P2</a:t>
-            </a:r>
-            <a:endParaRPr lang="en-US" sz="1200" dirty="0"/>
-          </a:p>
-        </p:txBody>
-      </p:sp>
-      <p:sp>
-        <p:nvSpPr>
           <p:cNvPr id="11" name="Text 9"/>
           <p:cNvSpPr/>
           <p:nvPr/>
         </p:nvSpPr>
         <p:spPr>
           <a:xfrm>
-            <a:off x="2651760" y="4251960"/>
-            <a:ext cx="2011680" cy="365760"/>
-          </a:xfrm>
-          <a:prstGeom prst="rect">
-            <a:avLst/>
-          </a:prstGeom>
-          <a:noFill/>
-          <a:ln/>
-        </p:spPr>
-        <p:txBody>
-          <a:bodyPr wrap="square" rtlCol="0" anchor="ctr"/>
-          <a:lstStyle/>
-          <a:p>
-            <a:pPr algn="ctr" indent="0" marL="0">
-              <a:buNone/>
-            </a:pPr>
-            <a:r>
-              <a:rPr lang="en-US" sz="1500" b="1" dirty="0">
-                <a:solidFill>
-                  <a:srgbClr val="16201C"/>
-                </a:solidFill>
-                <a:latin typeface="Arial" pitchFamily="34" charset="0"/>
-                <a:ea typeface="Arial" pitchFamily="34" charset="-122"/>
-                <a:cs typeface="Arial" pitchFamily="34" charset="-120"/>
-              </a:rPr>
-              <a:t>Cal.com setup</a:t>
-            </a:r>
-            <a:endParaRPr lang="en-US" sz="1500" dirty="0"/>
+            <a:off x="1188720" y="4800600"/>
+            <a:ext cx="4389120" cy="457200"/>
+          </a:xfrm>
+          <a:prstGeom prst="rect">
+            <a:avLst/>
+          </a:prstGeom>
+          <a:noFill/>
+          <a:ln/>
+        </p:spPr>
+        <p:txBody>
+          <a:bodyPr wrap="square" rtlCol="0" anchor="ctr"/>
+          <a:lstStyle/>
+          <a:p>
+            <a:pPr indent="0" marL="0">
+              <a:buNone/>
+            </a:pPr>
+            <a:r>
+              <a:rPr lang="en-US" sz="1700" b="1" dirty="0">
+                <a:solidFill>
+                  <a:srgbClr val="16513C"/>
+                </a:solidFill>
+                <a:latin typeface="Arial" pitchFamily="34" charset="0"/>
+                <a:ea typeface="Arial" pitchFamily="34" charset="-122"/>
+                <a:cs typeface="Arial" pitchFamily="34" charset="-120"/>
+              </a:rPr>
+              <a:t>Keep the enquiry form</a:t>
+            </a:r>
+            <a:endParaRPr lang="en-US" sz="1700" dirty="0"/>
           </a:p>
         </p:txBody>
       </p:sp>
@@ -8806,27 +8451,27 @@
         </p:nvSpPr>
         <p:spPr>
           <a:xfrm>
-            <a:off x="2514600" y="4617720"/>
-            <a:ext cx="2286000" cy="868680"/>
-          </a:xfrm>
-          <a:prstGeom prst="rect">
-            <a:avLst/>
-          </a:prstGeom>
-          <a:noFill/>
-          <a:ln/>
-        </p:spPr>
-        <p:txBody>
-          <a:bodyPr wrap="square" rtlCol="0" anchor="ctr"/>
-          <a:lstStyle/>
-          <a:p>
-            <a:pPr algn="ctr" indent="0" marL="0">
+            <a:off x="1188720" y="5303520"/>
+            <a:ext cx="4389120" cy="777240"/>
+          </a:xfrm>
+          <a:prstGeom prst="rect">
+            <a:avLst/>
+          </a:prstGeom>
+          <a:noFill/>
+          <a:ln/>
+        </p:spPr>
+        <p:txBody>
+          <a:bodyPr wrap="square" rtlCol="0" anchor="ctr"/>
+          <a:lstStyle/>
+          <a:p>
+            <a:pPr indent="0" marL="0">
               <a:lnSpc>
-                <a:spcPts val="1500"/>
+                <a:spcPts val="1800"/>
               </a:lnSpc>
               <a:buNone/>
             </a:pPr>
             <a:r>
-              <a:rPr lang="en-US" sz="1200" dirty="0">
+              <a:rPr lang="en-US" sz="1300" dirty="0">
                 <a:solidFill>
                   <a:srgbClr val="5A6661"/>
                 </a:solidFill>
@@ -8834,9 +8479,9 @@
                 <a:ea typeface="Arial" pitchFamily="34" charset="-122"/>
                 <a:cs typeface="Arial" pitchFamily="34" charset="-120"/>
               </a:rPr>
-              <a:t>Account, event type, availability and branding.</a:t>
-            </a:r>
-            <a:endParaRPr lang="en-US" sz="1200" dirty="0"/>
+              <a:t>Questions still go to the form; bookings go to the calendar.</a:t>
+            </a:r>
+            <a:endParaRPr lang="en-US" sz="1300" dirty="0"/>
           </a:p>
         </p:txBody>
       </p:sp>
@@ -8848,18 +8493,20 @@
         </p:nvSpPr>
         <p:spPr>
           <a:xfrm>
-            <a:off x="5806440" y="3520440"/>
-            <a:ext cx="548640" cy="548640"/>
-          </a:xfrm>
-          <a:prstGeom prst="ellipse">
-            <a:avLst/>
+            <a:off x="6355080" y="4526280"/>
+            <a:ext cx="5120640" cy="1737360"/>
+          </a:xfrm>
+          <a:prstGeom prst="roundRect">
+            <a:avLst>
+              <a:gd name="adj" fmla="val 4737"/>
+            </a:avLst>
           </a:prstGeom>
           <a:solidFill>
-            <a:srgbClr val="16513C"/>
+            <a:srgbClr val="F4F6F4"/>
           </a:solidFill>
-          <a:ln w="38100">
+          <a:ln w="12700">
             <a:solidFill>
-              <a:srgbClr val="FFFFFF"/>
+              <a:srgbClr val="E2E4E0"/>
             </a:solidFill>
             <a:prstDash val="solid"/>
           </a:ln>
@@ -8873,34 +8520,34 @@
         </p:nvSpPr>
         <p:spPr>
           <a:xfrm>
-            <a:off x="5806440" y="3520440"/>
-            <a:ext cx="548640" cy="548640"/>
-          </a:xfrm>
-          <a:prstGeom prst="rect">
-            <a:avLst/>
-          </a:prstGeom>
-          <a:noFill/>
-          <a:ln/>
-        </p:spPr>
-        <p:txBody>
-          <a:bodyPr wrap="square" rtlCol="0" anchor="ctr"/>
-          <a:lstStyle/>
-          <a:p>
-            <a:pPr algn="ctr" indent="0" marL="0">
-              <a:buNone/>
-            </a:pPr>
-            <a:r>
-              <a:rPr lang="en-US" sz="1200" b="1" dirty="0">
-                <a:solidFill>
-                  <a:srgbClr val="FFFFFF"/>
-                </a:solidFill>
-                <a:latin typeface="Courier New" pitchFamily="34" charset="0"/>
-                <a:ea typeface="Courier New" pitchFamily="34" charset="-122"/>
-                <a:cs typeface="Courier New" pitchFamily="34" charset="-120"/>
-              </a:rPr>
-              <a:t>P3</a:t>
-            </a:r>
-            <a:endParaRPr lang="en-US" sz="1200" dirty="0"/>
+            <a:off x="6720840" y="4800600"/>
+            <a:ext cx="4389120" cy="457200"/>
+          </a:xfrm>
+          <a:prstGeom prst="rect">
+            <a:avLst/>
+          </a:prstGeom>
+          <a:noFill/>
+          <a:ln/>
+        </p:spPr>
+        <p:txBody>
+          <a:bodyPr wrap="square" rtlCol="0" anchor="ctr"/>
+          <a:lstStyle/>
+          <a:p>
+            <a:pPr indent="0" marL="0">
+              <a:buNone/>
+            </a:pPr>
+            <a:r>
+              <a:rPr lang="en-US" sz="1700" b="1" dirty="0">
+                <a:solidFill>
+                  <a:srgbClr val="16513C"/>
+                </a:solidFill>
+                <a:latin typeface="Arial" pitchFamily="34" charset="0"/>
+                <a:ea typeface="Arial" pitchFamily="34" charset="-122"/>
+                <a:cs typeface="Arial" pitchFamily="34" charset="-120"/>
+              </a:rPr>
+              <a:t>Promote in follow-ups</a:t>
+            </a:r>
+            <a:endParaRPr lang="en-US" sz="1700" dirty="0"/>
           </a:p>
         </p:txBody>
       </p:sp>
@@ -8912,66 +8559,27 @@
         </p:nvSpPr>
         <p:spPr>
           <a:xfrm>
-            <a:off x="5074920" y="2377440"/>
-            <a:ext cx="2011680" cy="365760"/>
-          </a:xfrm>
-          <a:prstGeom prst="rect">
-            <a:avLst/>
-          </a:prstGeom>
-          <a:noFill/>
-          <a:ln/>
-        </p:spPr>
-        <p:txBody>
-          <a:bodyPr wrap="square" rtlCol="0" anchor="ctr"/>
-          <a:lstStyle/>
-          <a:p>
-            <a:pPr algn="ctr" indent="0" marL="0">
-              <a:buNone/>
-            </a:pPr>
-            <a:r>
-              <a:rPr lang="en-US" sz="1500" b="1" dirty="0">
-                <a:solidFill>
-                  <a:srgbClr val="16201C"/>
-                </a:solidFill>
-                <a:latin typeface="Arial" pitchFamily="34" charset="0"/>
-                <a:ea typeface="Arial" pitchFamily="34" charset="-122"/>
-                <a:cs typeface="Arial" pitchFamily="34" charset="-120"/>
-              </a:rPr>
-              <a:t>Go live</a:t>
-            </a:r>
-            <a:endParaRPr lang="en-US" sz="1500" dirty="0"/>
-          </a:p>
-        </p:txBody>
-      </p:sp>
-      <p:sp>
-        <p:nvSpPr>
-          <p:cNvPr id="16" name="Text 14"/>
-          <p:cNvSpPr/>
-          <p:nvPr/>
-        </p:nvSpPr>
-        <p:spPr>
-          <a:xfrm>
-            <a:off x="4937760" y="2743200"/>
-            <a:ext cx="2286000" cy="868680"/>
-          </a:xfrm>
-          <a:prstGeom prst="rect">
-            <a:avLst/>
-          </a:prstGeom>
-          <a:noFill/>
-          <a:ln/>
-        </p:spPr>
-        <p:txBody>
-          <a:bodyPr wrap="square" rtlCol="0" anchor="ctr"/>
-          <a:lstStyle/>
-          <a:p>
-            <a:pPr algn="ctr" indent="0" marL="0">
+            <a:off x="6720840" y="5303520"/>
+            <a:ext cx="4389120" cy="777240"/>
+          </a:xfrm>
+          <a:prstGeom prst="rect">
+            <a:avLst/>
+          </a:prstGeom>
+          <a:noFill/>
+          <a:ln/>
+        </p:spPr>
+        <p:txBody>
+          <a:bodyPr wrap="square" rtlCol="0" anchor="ctr"/>
+          <a:lstStyle/>
+          <a:p>
+            <a:pPr indent="0" marL="0">
               <a:lnSpc>
-                <a:spcPts val="1500"/>
+                <a:spcPts val="1800"/>
               </a:lnSpc>
               <a:buNone/>
             </a:pPr>
             <a:r>
-              <a:rPr lang="en-US" sz="1200" dirty="0">
+              <a:rPr lang="en-US" sz="1300" dirty="0">
                 <a:solidFill>
                   <a:srgbClr val="5A6661"/>
                 </a:solidFill>
@@ -8979,299 +8587,9 @@
                 <a:ea typeface="Arial" pitchFamily="34" charset="-122"/>
                 <a:cs typeface="Arial" pitchFamily="34" charset="-120"/>
               </a:rPr>
-              <a:t>Publish + add the 'Book a consultation' button.</a:t>
-            </a:r>
-            <a:endParaRPr lang="en-US" sz="1200" dirty="0"/>
-          </a:p>
-        </p:txBody>
-      </p:sp>
-      <p:sp>
-        <p:nvSpPr>
-          <p:cNvPr id="17" name="Shape 15"/>
-          <p:cNvSpPr/>
-          <p:nvPr/>
-        </p:nvSpPr>
-        <p:spPr>
-          <a:xfrm>
-            <a:off x="8229600" y="3520440"/>
-            <a:ext cx="548640" cy="548640"/>
-          </a:xfrm>
-          <a:prstGeom prst="ellipse">
-            <a:avLst/>
-          </a:prstGeom>
-          <a:solidFill>
-            <a:srgbClr val="16513C"/>
-          </a:solidFill>
-          <a:ln w="38100">
-            <a:solidFill>
-              <a:srgbClr val="FFFFFF"/>
-            </a:solidFill>
-            <a:prstDash val="solid"/>
-          </a:ln>
-        </p:spPr>
-      </p:sp>
-      <p:sp>
-        <p:nvSpPr>
-          <p:cNvPr id="18" name="Text 16"/>
-          <p:cNvSpPr/>
-          <p:nvPr/>
-        </p:nvSpPr>
-        <p:spPr>
-          <a:xfrm>
-            <a:off x="8229600" y="3520440"/>
-            <a:ext cx="548640" cy="548640"/>
-          </a:xfrm>
-          <a:prstGeom prst="rect">
-            <a:avLst/>
-          </a:prstGeom>
-          <a:noFill/>
-          <a:ln/>
-        </p:spPr>
-        <p:txBody>
-          <a:bodyPr wrap="square" rtlCol="0" anchor="ctr"/>
-          <a:lstStyle/>
-          <a:p>
-            <a:pPr algn="ctr" indent="0" marL="0">
-              <a:buNone/>
-            </a:pPr>
-            <a:r>
-              <a:rPr lang="en-US" sz="1200" b="1" dirty="0">
-                <a:solidFill>
-                  <a:srgbClr val="FFFFFF"/>
-                </a:solidFill>
-                <a:latin typeface="Courier New" pitchFamily="34" charset="0"/>
-                <a:ea typeface="Courier New" pitchFamily="34" charset="-122"/>
-                <a:cs typeface="Courier New" pitchFamily="34" charset="-120"/>
-              </a:rPr>
-              <a:t>P4</a:t>
-            </a:r>
-            <a:endParaRPr lang="en-US" sz="1200" dirty="0"/>
-          </a:p>
-        </p:txBody>
-      </p:sp>
-      <p:sp>
-        <p:nvSpPr>
-          <p:cNvPr id="19" name="Text 17"/>
-          <p:cNvSpPr/>
-          <p:nvPr/>
-        </p:nvSpPr>
-        <p:spPr>
-          <a:xfrm>
-            <a:off x="7498080" y="4251960"/>
-            <a:ext cx="2011680" cy="365760"/>
-          </a:xfrm>
-          <a:prstGeom prst="rect">
-            <a:avLst/>
-          </a:prstGeom>
-          <a:noFill/>
-          <a:ln/>
-        </p:spPr>
-        <p:txBody>
-          <a:bodyPr wrap="square" rtlCol="0" anchor="ctr"/>
-          <a:lstStyle/>
-          <a:p>
-            <a:pPr algn="ctr" indent="0" marL="0">
-              <a:buNone/>
-            </a:pPr>
-            <a:r>
-              <a:rPr lang="en-US" sz="1500" b="1" dirty="0">
-                <a:solidFill>
-                  <a:srgbClr val="16201C"/>
-                </a:solidFill>
-                <a:latin typeface="Arial" pitchFamily="34" charset="0"/>
-                <a:ea typeface="Arial" pitchFamily="34" charset="-122"/>
-                <a:cs typeface="Arial" pitchFamily="34" charset="-120"/>
-              </a:rPr>
-              <a:t>Expand</a:t>
-            </a:r>
-            <a:endParaRPr lang="en-US" sz="1500" dirty="0"/>
-          </a:p>
-        </p:txBody>
-      </p:sp>
-      <p:sp>
-        <p:nvSpPr>
-          <p:cNvPr id="20" name="Text 18"/>
-          <p:cNvSpPr/>
-          <p:nvPr/>
-        </p:nvSpPr>
-        <p:spPr>
-          <a:xfrm>
-            <a:off x="7360920" y="4617720"/>
-            <a:ext cx="2286000" cy="868680"/>
-          </a:xfrm>
-          <a:prstGeom prst="rect">
-            <a:avLst/>
-          </a:prstGeom>
-          <a:noFill/>
-          <a:ln/>
-        </p:spPr>
-        <p:txBody>
-          <a:bodyPr wrap="square" rtlCol="0" anchor="ctr"/>
-          <a:lstStyle/>
-          <a:p>
-            <a:pPr algn="ctr" indent="0" marL="0">
-              <a:lnSpc>
-                <a:spcPts val="1500"/>
-              </a:lnSpc>
-              <a:buNone/>
-            </a:pPr>
-            <a:r>
-              <a:rPr lang="en-US" sz="1200" dirty="0">
-                <a:solidFill>
-                  <a:srgbClr val="5A6661"/>
-                </a:solidFill>
-                <a:latin typeface="Arial" pitchFamily="34" charset="0"/>
-                <a:ea typeface="Arial" pitchFamily="34" charset="-122"/>
-                <a:cs typeface="Arial" pitchFamily="34" charset="-120"/>
-              </a:rPr>
-              <a:t>Add booking to other services you offer.</a:t>
-            </a:r>
-            <a:endParaRPr lang="en-US" sz="1200" dirty="0"/>
-          </a:p>
-        </p:txBody>
-      </p:sp>
-      <p:sp>
-        <p:nvSpPr>
-          <p:cNvPr id="21" name="Shape 19"/>
-          <p:cNvSpPr/>
-          <p:nvPr/>
-        </p:nvSpPr>
-        <p:spPr>
-          <a:xfrm>
-            <a:off x="10652760" y="3520440"/>
-            <a:ext cx="548640" cy="548640"/>
-          </a:xfrm>
-          <a:prstGeom prst="ellipse">
-            <a:avLst/>
-          </a:prstGeom>
-          <a:solidFill>
-            <a:srgbClr val="16513C"/>
-          </a:solidFill>
-          <a:ln w="38100">
-            <a:solidFill>
-              <a:srgbClr val="FFFFFF"/>
-            </a:solidFill>
-            <a:prstDash val="solid"/>
-          </a:ln>
-        </p:spPr>
-      </p:sp>
-      <p:sp>
-        <p:nvSpPr>
-          <p:cNvPr id="22" name="Text 20"/>
-          <p:cNvSpPr/>
-          <p:nvPr/>
-        </p:nvSpPr>
-        <p:spPr>
-          <a:xfrm>
-            <a:off x="10652760" y="3520440"/>
-            <a:ext cx="548640" cy="548640"/>
-          </a:xfrm>
-          <a:prstGeom prst="rect">
-            <a:avLst/>
-          </a:prstGeom>
-          <a:noFill/>
-          <a:ln/>
-        </p:spPr>
-        <p:txBody>
-          <a:bodyPr wrap="square" rtlCol="0" anchor="ctr"/>
-          <a:lstStyle/>
-          <a:p>
-            <a:pPr algn="ctr" indent="0" marL="0">
-              <a:buNone/>
-            </a:pPr>
-            <a:r>
-              <a:rPr lang="en-US" sz="1200" b="1" dirty="0">
-                <a:solidFill>
-                  <a:srgbClr val="FFFFFF"/>
-                </a:solidFill>
-                <a:latin typeface="Courier New" pitchFamily="34" charset="0"/>
-                <a:ea typeface="Courier New" pitchFamily="34" charset="-122"/>
-                <a:cs typeface="Courier New" pitchFamily="34" charset="-120"/>
-              </a:rPr>
-              <a:t>P5</a:t>
-            </a:r>
-            <a:endParaRPr lang="en-US" sz="1200" dirty="0"/>
-          </a:p>
-        </p:txBody>
-      </p:sp>
-      <p:sp>
-        <p:nvSpPr>
-          <p:cNvPr id="23" name="Text 21"/>
-          <p:cNvSpPr/>
-          <p:nvPr/>
-        </p:nvSpPr>
-        <p:spPr>
-          <a:xfrm>
-            <a:off x="9921240" y="2377440"/>
-            <a:ext cx="2011680" cy="365760"/>
-          </a:xfrm>
-          <a:prstGeom prst="rect">
-            <a:avLst/>
-          </a:prstGeom>
-          <a:noFill/>
-          <a:ln/>
-        </p:spPr>
-        <p:txBody>
-          <a:bodyPr wrap="square" rtlCol="0" anchor="ctr"/>
-          <a:lstStyle/>
-          <a:p>
-            <a:pPr algn="ctr" indent="0" marL="0">
-              <a:buNone/>
-            </a:pPr>
-            <a:r>
-              <a:rPr lang="en-US" sz="1500" b="1" dirty="0">
-                <a:solidFill>
-                  <a:srgbClr val="16201C"/>
-                </a:solidFill>
-                <a:latin typeface="Arial" pitchFamily="34" charset="0"/>
-                <a:ea typeface="Arial" pitchFamily="34" charset="-122"/>
-                <a:cs typeface="Arial" pitchFamily="34" charset="-120"/>
-              </a:rPr>
-              <a:t>Insights</a:t>
-            </a:r>
-            <a:endParaRPr lang="en-US" sz="1500" dirty="0"/>
-          </a:p>
-        </p:txBody>
-      </p:sp>
-      <p:sp>
-        <p:nvSpPr>
-          <p:cNvPr id="24" name="Text 22"/>
-          <p:cNvSpPr/>
-          <p:nvPr/>
-        </p:nvSpPr>
-        <p:spPr>
-          <a:xfrm>
-            <a:off x="9784080" y="2743200"/>
-            <a:ext cx="2286000" cy="868680"/>
-          </a:xfrm>
-          <a:prstGeom prst="rect">
-            <a:avLst/>
-          </a:prstGeom>
-          <a:noFill/>
-          <a:ln/>
-        </p:spPr>
-        <p:txBody>
-          <a:bodyPr wrap="square" rtlCol="0" anchor="ctr"/>
-          <a:lstStyle/>
-          <a:p>
-            <a:pPr algn="ctr" indent="0" marL="0">
-              <a:lnSpc>
-                <a:spcPts val="1500"/>
-              </a:lnSpc>
-              <a:buNone/>
-            </a:pPr>
-            <a:r>
-              <a:rPr lang="en-US" sz="1200" dirty="0">
-                <a:solidFill>
-                  <a:srgbClr val="5A6661"/>
-                </a:solidFill>
-                <a:latin typeface="Arial" pitchFamily="34" charset="0"/>
-                <a:ea typeface="Arial" pitchFamily="34" charset="-122"/>
-                <a:cs typeface="Arial" pitchFamily="34" charset="-120"/>
-              </a:rPr>
-              <a:t>Review booking patterns and busy periods.</a:t>
-            </a:r>
-            <a:endParaRPr lang="en-US" sz="1200" dirty="0"/>
+              <a:t>Drop the booking link in quotes and after-visit emails.</a:t>
+            </a:r>
+            <a:endParaRPr lang="en-US" sz="1300" dirty="0"/>
           </a:p>
         </p:txBody>
       </p:sp>

</xml_diff>